<commit_message>
update(doc): removed sections from the presentation slides.
</commit_message>
<xml_diff>
--- a/docs/AI_Safety_Observatory_Africa.pptx
+++ b/docs/AI_Safety_Observatory_Africa.pptx
@@ -5,23 +5,23 @@
     <p:sldMasterId id="2147483648" r:id="rId1"/>
   </p:sldMasterIdLst>
   <p:sldIdLst>
-    <p:sldId id="256" r:id="rId7"/>
-    <p:sldId id="257" r:id="rId8"/>
-    <p:sldId id="258" r:id="rId9"/>
-    <p:sldId id="259" r:id="rId10"/>
-    <p:sldId id="260" r:id="rId11"/>
-    <p:sldId id="261" r:id="rId12"/>
-    <p:sldId id="262" r:id="rId13"/>
-    <p:sldId id="263" r:id="rId14"/>
-    <p:sldId id="264" r:id="rId15"/>
-    <p:sldId id="265" r:id="rId16"/>
-    <p:sldId id="266" r:id="rId17"/>
-    <p:sldId id="267" r:id="rId18"/>
-    <p:sldId id="268" r:id="rId19"/>
-    <p:sldId id="269" r:id="rId20"/>
-    <p:sldId id="270" r:id="rId21"/>
+    <p:sldId id="256" r:id="rId2"/>
+    <p:sldId id="257" r:id="rId3"/>
+    <p:sldId id="258" r:id="rId4"/>
+    <p:sldId id="259" r:id="rId5"/>
+    <p:sldId id="260" r:id="rId6"/>
+    <p:sldId id="261" r:id="rId7"/>
+    <p:sldId id="262" r:id="rId8"/>
+    <p:sldId id="263" r:id="rId9"/>
+    <p:sldId id="264" r:id="rId10"/>
+    <p:sldId id="265" r:id="rId11"/>
+    <p:sldId id="266" r:id="rId12"/>
+    <p:sldId id="267" r:id="rId13"/>
+    <p:sldId id="268" r:id="rId14"/>
+    <p:sldId id="269" r:id="rId15"/>
+    <p:sldId id="270" r:id="rId16"/>
   </p:sldIdLst>
-  <p:sldSz cx="12191695" cy="6858000" type="screen4x3"/>
+  <p:sldSz cx="12192000" cy="6858000"/>
   <p:notesSz cx="6858000" cy="9144000"/>
   <p:defaultTextStyle>
     <a:defPPr>
@@ -118,7 +118,270 @@
       </a:defRPr>
     </a:lvl9pPr>
   </p:defaultTextStyle>
+  <p:extLst>
+    <p:ext uri="{EFAFB233-063F-42B5-8137-9DF3F51BA10A}">
+      <p15:sldGuideLst xmlns:p15="http://schemas.microsoft.com/office/powerpoint/2012/main">
+        <p15:guide id="1" orient="horz" pos="2160">
+          <p15:clr>
+            <a:srgbClr val="A4A3A4"/>
+          </p15:clr>
+        </p15:guide>
+        <p15:guide id="2" pos="2880">
+          <p15:clr>
+            <a:srgbClr val="A4A3A4"/>
+          </p15:clr>
+        </p15:guide>
+      </p15:sldGuideLst>
+    </p:ext>
+  </p:extLst>
 </p:presentation>
+</file>
+
+<file path=ppt/changesInfos/changesInfo1.xml><?xml version="1.0" encoding="utf-8"?>
+<pc:chgInfo xmlns:a="http://schemas.openxmlformats.org/drawingml/2006/main" xmlns:r="http://schemas.openxmlformats.org/officeDocument/2006/relationships" xmlns:ac="http://schemas.microsoft.com/office/drawing/2013/main/command" xmlns:pc="http://schemas.microsoft.com/office/powerpoint/2013/main/command">
+  <pc:docChgLst>
+    <pc:chgData name="Rashaad Samsodien" userId="13cc2e93-c31d-4200-be92-9a1309266b79" providerId="ADAL" clId="{577376F7-5811-4CF8-9E0E-86F4D3718250}"/>
+    <pc:docChg chg="custSel modSld">
+      <pc:chgData name="Rashaad Samsodien" userId="13cc2e93-c31d-4200-be92-9a1309266b79" providerId="ADAL" clId="{577376F7-5811-4CF8-9E0E-86F4D3718250}" dt="2026-06-21T08:51:41.359" v="19" actId="478"/>
+      <pc:docMkLst>
+        <pc:docMk/>
+      </pc:docMkLst>
+      <pc:sldChg chg="delSp modSp mod">
+        <pc:chgData name="Rashaad Samsodien" userId="13cc2e93-c31d-4200-be92-9a1309266b79" providerId="ADAL" clId="{577376F7-5811-4CF8-9E0E-86F4D3718250}" dt="2026-06-21T08:47:15.383" v="2" actId="478"/>
+        <pc:sldMkLst>
+          <pc:docMk/>
+          <pc:sldMk cId="0" sldId="256"/>
+        </pc:sldMkLst>
+        <pc:spChg chg="del mod">
+          <ac:chgData name="Rashaad Samsodien" userId="13cc2e93-c31d-4200-be92-9a1309266b79" providerId="ADAL" clId="{577376F7-5811-4CF8-9E0E-86F4D3718250}" dt="2026-06-21T08:47:15.383" v="2" actId="478"/>
+          <ac:spMkLst>
+            <pc:docMk/>
+            <pc:sldMk cId="0" sldId="256"/>
+            <ac:spMk id="3" creationId="{00000000-0000-0000-0000-000000000000}"/>
+          </ac:spMkLst>
+        </pc:spChg>
+      </pc:sldChg>
+      <pc:sldChg chg="delSp modSp mod">
+        <pc:chgData name="Rashaad Samsodien" userId="13cc2e93-c31d-4200-be92-9a1309266b79" providerId="ADAL" clId="{577376F7-5811-4CF8-9E0E-86F4D3718250}" dt="2026-06-21T08:47:26.619" v="4" actId="478"/>
+        <pc:sldMkLst>
+          <pc:docMk/>
+          <pc:sldMk cId="0" sldId="257"/>
+        </pc:sldMkLst>
+        <pc:spChg chg="del mod">
+          <ac:chgData name="Rashaad Samsodien" userId="13cc2e93-c31d-4200-be92-9a1309266b79" providerId="ADAL" clId="{577376F7-5811-4CF8-9E0E-86F4D3718250}" dt="2026-06-21T08:47:26.619" v="4" actId="478"/>
+          <ac:spMkLst>
+            <pc:docMk/>
+            <pc:sldMk cId="0" sldId="257"/>
+            <ac:spMk id="2" creationId="{00000000-0000-0000-0000-000000000000}"/>
+          </ac:spMkLst>
+        </pc:spChg>
+      </pc:sldChg>
+      <pc:sldChg chg="delSp modSp mod">
+        <pc:chgData name="Rashaad Samsodien" userId="13cc2e93-c31d-4200-be92-9a1309266b79" providerId="ADAL" clId="{577376F7-5811-4CF8-9E0E-86F4D3718250}" dt="2026-06-21T08:47:34.671" v="6" actId="478"/>
+        <pc:sldMkLst>
+          <pc:docMk/>
+          <pc:sldMk cId="0" sldId="258"/>
+        </pc:sldMkLst>
+        <pc:spChg chg="del mod">
+          <ac:chgData name="Rashaad Samsodien" userId="13cc2e93-c31d-4200-be92-9a1309266b79" providerId="ADAL" clId="{577376F7-5811-4CF8-9E0E-86F4D3718250}" dt="2026-06-21T08:47:34.671" v="6" actId="478"/>
+          <ac:spMkLst>
+            <pc:docMk/>
+            <pc:sldMk cId="0" sldId="258"/>
+            <ac:spMk id="2" creationId="{00000000-0000-0000-0000-000000000000}"/>
+          </ac:spMkLst>
+        </pc:spChg>
+      </pc:sldChg>
+      <pc:sldChg chg="delSp mod">
+        <pc:chgData name="Rashaad Samsodien" userId="13cc2e93-c31d-4200-be92-9a1309266b79" providerId="ADAL" clId="{577376F7-5811-4CF8-9E0E-86F4D3718250}" dt="2026-06-21T08:47:38.986" v="7" actId="478"/>
+        <pc:sldMkLst>
+          <pc:docMk/>
+          <pc:sldMk cId="0" sldId="259"/>
+        </pc:sldMkLst>
+        <pc:spChg chg="del">
+          <ac:chgData name="Rashaad Samsodien" userId="13cc2e93-c31d-4200-be92-9a1309266b79" providerId="ADAL" clId="{577376F7-5811-4CF8-9E0E-86F4D3718250}" dt="2026-06-21T08:47:38.986" v="7" actId="478"/>
+          <ac:spMkLst>
+            <pc:docMk/>
+            <pc:sldMk cId="0" sldId="259"/>
+            <ac:spMk id="2" creationId="{00000000-0000-0000-0000-000000000000}"/>
+          </ac:spMkLst>
+        </pc:spChg>
+      </pc:sldChg>
+      <pc:sldChg chg="delSp mod">
+        <pc:chgData name="Rashaad Samsodien" userId="13cc2e93-c31d-4200-be92-9a1309266b79" providerId="ADAL" clId="{577376F7-5811-4CF8-9E0E-86F4D3718250}" dt="2026-06-21T08:47:44.771" v="8" actId="478"/>
+        <pc:sldMkLst>
+          <pc:docMk/>
+          <pc:sldMk cId="0" sldId="260"/>
+        </pc:sldMkLst>
+        <pc:spChg chg="del">
+          <ac:chgData name="Rashaad Samsodien" userId="13cc2e93-c31d-4200-be92-9a1309266b79" providerId="ADAL" clId="{577376F7-5811-4CF8-9E0E-86F4D3718250}" dt="2026-06-21T08:47:44.771" v="8" actId="478"/>
+          <ac:spMkLst>
+            <pc:docMk/>
+            <pc:sldMk cId="0" sldId="260"/>
+            <ac:spMk id="2" creationId="{00000000-0000-0000-0000-000000000000}"/>
+          </ac:spMkLst>
+        </pc:spChg>
+      </pc:sldChg>
+      <pc:sldChg chg="delSp mod">
+        <pc:chgData name="Rashaad Samsodien" userId="13cc2e93-c31d-4200-be92-9a1309266b79" providerId="ADAL" clId="{577376F7-5811-4CF8-9E0E-86F4D3718250}" dt="2026-06-21T08:47:52.275" v="9" actId="478"/>
+        <pc:sldMkLst>
+          <pc:docMk/>
+          <pc:sldMk cId="0" sldId="261"/>
+        </pc:sldMkLst>
+        <pc:spChg chg="del">
+          <ac:chgData name="Rashaad Samsodien" userId="13cc2e93-c31d-4200-be92-9a1309266b79" providerId="ADAL" clId="{577376F7-5811-4CF8-9E0E-86F4D3718250}" dt="2026-06-21T08:47:52.275" v="9" actId="478"/>
+          <ac:spMkLst>
+            <pc:docMk/>
+            <pc:sldMk cId="0" sldId="261"/>
+            <ac:spMk id="2" creationId="{00000000-0000-0000-0000-000000000000}"/>
+          </ac:spMkLst>
+        </pc:spChg>
+      </pc:sldChg>
+      <pc:sldChg chg="delSp mod">
+        <pc:chgData name="Rashaad Samsodien" userId="13cc2e93-c31d-4200-be92-9a1309266b79" providerId="ADAL" clId="{577376F7-5811-4CF8-9E0E-86F4D3718250}" dt="2026-06-21T08:50:53.773" v="10" actId="478"/>
+        <pc:sldMkLst>
+          <pc:docMk/>
+          <pc:sldMk cId="0" sldId="262"/>
+        </pc:sldMkLst>
+        <pc:spChg chg="del">
+          <ac:chgData name="Rashaad Samsodien" userId="13cc2e93-c31d-4200-be92-9a1309266b79" providerId="ADAL" clId="{577376F7-5811-4CF8-9E0E-86F4D3718250}" dt="2026-06-21T08:50:53.773" v="10" actId="478"/>
+          <ac:spMkLst>
+            <pc:docMk/>
+            <pc:sldMk cId="0" sldId="262"/>
+            <ac:spMk id="2" creationId="{00000000-0000-0000-0000-000000000000}"/>
+          </ac:spMkLst>
+        </pc:spChg>
+      </pc:sldChg>
+      <pc:sldChg chg="delSp mod">
+        <pc:chgData name="Rashaad Samsodien" userId="13cc2e93-c31d-4200-be92-9a1309266b79" providerId="ADAL" clId="{577376F7-5811-4CF8-9E0E-86F4D3718250}" dt="2026-06-21T08:50:58.302" v="11" actId="478"/>
+        <pc:sldMkLst>
+          <pc:docMk/>
+          <pc:sldMk cId="0" sldId="263"/>
+        </pc:sldMkLst>
+        <pc:spChg chg="del">
+          <ac:chgData name="Rashaad Samsodien" userId="13cc2e93-c31d-4200-be92-9a1309266b79" providerId="ADAL" clId="{577376F7-5811-4CF8-9E0E-86F4D3718250}" dt="2026-06-21T08:50:58.302" v="11" actId="478"/>
+          <ac:spMkLst>
+            <pc:docMk/>
+            <pc:sldMk cId="0" sldId="263"/>
+            <ac:spMk id="2" creationId="{00000000-0000-0000-0000-000000000000}"/>
+          </ac:spMkLst>
+        </pc:spChg>
+      </pc:sldChg>
+      <pc:sldChg chg="delSp mod">
+        <pc:chgData name="Rashaad Samsodien" userId="13cc2e93-c31d-4200-be92-9a1309266b79" providerId="ADAL" clId="{577376F7-5811-4CF8-9E0E-86F4D3718250}" dt="2026-06-21T08:51:02.183" v="12" actId="478"/>
+        <pc:sldMkLst>
+          <pc:docMk/>
+          <pc:sldMk cId="0" sldId="264"/>
+        </pc:sldMkLst>
+        <pc:spChg chg="del">
+          <ac:chgData name="Rashaad Samsodien" userId="13cc2e93-c31d-4200-be92-9a1309266b79" providerId="ADAL" clId="{577376F7-5811-4CF8-9E0E-86F4D3718250}" dt="2026-06-21T08:51:02.183" v="12" actId="478"/>
+          <ac:spMkLst>
+            <pc:docMk/>
+            <pc:sldMk cId="0" sldId="264"/>
+            <ac:spMk id="2" creationId="{00000000-0000-0000-0000-000000000000}"/>
+          </ac:spMkLst>
+        </pc:spChg>
+      </pc:sldChg>
+      <pc:sldChg chg="delSp mod">
+        <pc:chgData name="Rashaad Samsodien" userId="13cc2e93-c31d-4200-be92-9a1309266b79" providerId="ADAL" clId="{577376F7-5811-4CF8-9E0E-86F4D3718250}" dt="2026-06-21T08:51:05.137" v="13" actId="478"/>
+        <pc:sldMkLst>
+          <pc:docMk/>
+          <pc:sldMk cId="0" sldId="265"/>
+        </pc:sldMkLst>
+        <pc:spChg chg="del">
+          <ac:chgData name="Rashaad Samsodien" userId="13cc2e93-c31d-4200-be92-9a1309266b79" providerId="ADAL" clId="{577376F7-5811-4CF8-9E0E-86F4D3718250}" dt="2026-06-21T08:51:05.137" v="13" actId="478"/>
+          <ac:spMkLst>
+            <pc:docMk/>
+            <pc:sldMk cId="0" sldId="265"/>
+            <ac:spMk id="2" creationId="{00000000-0000-0000-0000-000000000000}"/>
+          </ac:spMkLst>
+        </pc:spChg>
+      </pc:sldChg>
+      <pc:sldChg chg="delSp mod">
+        <pc:chgData name="Rashaad Samsodien" userId="13cc2e93-c31d-4200-be92-9a1309266b79" providerId="ADAL" clId="{577376F7-5811-4CF8-9E0E-86F4D3718250}" dt="2026-06-21T08:51:09.226" v="14" actId="478"/>
+        <pc:sldMkLst>
+          <pc:docMk/>
+          <pc:sldMk cId="0" sldId="266"/>
+        </pc:sldMkLst>
+        <pc:spChg chg="del">
+          <ac:chgData name="Rashaad Samsodien" userId="13cc2e93-c31d-4200-be92-9a1309266b79" providerId="ADAL" clId="{577376F7-5811-4CF8-9E0E-86F4D3718250}" dt="2026-06-21T08:51:09.226" v="14" actId="478"/>
+          <ac:spMkLst>
+            <pc:docMk/>
+            <pc:sldMk cId="0" sldId="266"/>
+            <ac:spMk id="2" creationId="{00000000-0000-0000-0000-000000000000}"/>
+          </ac:spMkLst>
+        </pc:spChg>
+      </pc:sldChg>
+      <pc:sldChg chg="delSp mod">
+        <pc:chgData name="Rashaad Samsodien" userId="13cc2e93-c31d-4200-be92-9a1309266b79" providerId="ADAL" clId="{577376F7-5811-4CF8-9E0E-86F4D3718250}" dt="2026-06-21T08:51:12.336" v="15" actId="478"/>
+        <pc:sldMkLst>
+          <pc:docMk/>
+          <pc:sldMk cId="0" sldId="267"/>
+        </pc:sldMkLst>
+        <pc:spChg chg="del">
+          <ac:chgData name="Rashaad Samsodien" userId="13cc2e93-c31d-4200-be92-9a1309266b79" providerId="ADAL" clId="{577376F7-5811-4CF8-9E0E-86F4D3718250}" dt="2026-06-21T08:51:12.336" v="15" actId="478"/>
+          <ac:spMkLst>
+            <pc:docMk/>
+            <pc:sldMk cId="0" sldId="267"/>
+            <ac:spMk id="2" creationId="{00000000-0000-0000-0000-000000000000}"/>
+          </ac:spMkLst>
+        </pc:spChg>
+      </pc:sldChg>
+      <pc:sldChg chg="delSp mod">
+        <pc:chgData name="Rashaad Samsodien" userId="13cc2e93-c31d-4200-be92-9a1309266b79" providerId="ADAL" clId="{577376F7-5811-4CF8-9E0E-86F4D3718250}" dt="2026-06-21T08:51:17.200" v="16" actId="478"/>
+        <pc:sldMkLst>
+          <pc:docMk/>
+          <pc:sldMk cId="0" sldId="268"/>
+        </pc:sldMkLst>
+        <pc:spChg chg="del">
+          <ac:chgData name="Rashaad Samsodien" userId="13cc2e93-c31d-4200-be92-9a1309266b79" providerId="ADAL" clId="{577376F7-5811-4CF8-9E0E-86F4D3718250}" dt="2026-06-21T08:51:17.200" v="16" actId="478"/>
+          <ac:spMkLst>
+            <pc:docMk/>
+            <pc:sldMk cId="0" sldId="268"/>
+            <ac:spMk id="2" creationId="{00000000-0000-0000-0000-000000000000}"/>
+          </ac:spMkLst>
+        </pc:spChg>
+      </pc:sldChg>
+      <pc:sldChg chg="delSp mod">
+        <pc:chgData name="Rashaad Samsodien" userId="13cc2e93-c31d-4200-be92-9a1309266b79" providerId="ADAL" clId="{577376F7-5811-4CF8-9E0E-86F4D3718250}" dt="2026-06-21T08:51:21.159" v="17" actId="478"/>
+        <pc:sldMkLst>
+          <pc:docMk/>
+          <pc:sldMk cId="0" sldId="269"/>
+        </pc:sldMkLst>
+        <pc:spChg chg="del">
+          <ac:chgData name="Rashaad Samsodien" userId="13cc2e93-c31d-4200-be92-9a1309266b79" providerId="ADAL" clId="{577376F7-5811-4CF8-9E0E-86F4D3718250}" dt="2026-06-21T08:51:21.159" v="17" actId="478"/>
+          <ac:spMkLst>
+            <pc:docMk/>
+            <pc:sldMk cId="0" sldId="269"/>
+            <ac:spMk id="2" creationId="{00000000-0000-0000-0000-000000000000}"/>
+          </ac:spMkLst>
+        </pc:spChg>
+      </pc:sldChg>
+      <pc:sldChg chg="delSp mod">
+        <pc:chgData name="Rashaad Samsodien" userId="13cc2e93-c31d-4200-be92-9a1309266b79" providerId="ADAL" clId="{577376F7-5811-4CF8-9E0E-86F4D3718250}" dt="2026-06-21T08:51:41.359" v="19" actId="478"/>
+        <pc:sldMkLst>
+          <pc:docMk/>
+          <pc:sldMk cId="0" sldId="270"/>
+        </pc:sldMkLst>
+        <pc:spChg chg="del">
+          <ac:chgData name="Rashaad Samsodien" userId="13cc2e93-c31d-4200-be92-9a1309266b79" providerId="ADAL" clId="{577376F7-5811-4CF8-9E0E-86F4D3718250}" dt="2026-06-21T08:51:26.695" v="18" actId="478"/>
+          <ac:spMkLst>
+            <pc:docMk/>
+            <pc:sldMk cId="0" sldId="270"/>
+            <ac:spMk id="2" creationId="{00000000-0000-0000-0000-000000000000}"/>
+          </ac:spMkLst>
+        </pc:spChg>
+        <pc:spChg chg="del">
+          <ac:chgData name="Rashaad Samsodien" userId="13cc2e93-c31d-4200-be92-9a1309266b79" providerId="ADAL" clId="{577376F7-5811-4CF8-9E0E-86F4D3718250}" dt="2026-06-21T08:51:41.359" v="19" actId="478"/>
+          <ac:spMkLst>
+            <pc:docMk/>
+            <pc:sldMk cId="0" sldId="270"/>
+            <ac:spMk id="5" creationId="{00000000-0000-0000-0000-000000000000}"/>
+          </ac:spMkLst>
+        </pc:spChg>
+      </pc:sldChg>
+    </pc:docChg>
+  </pc:docChgLst>
+</pc:chgInfo>
 </file>
 
 <file path=ppt/slideLayouts/slideLayout1.xml><?xml version="1.0" encoding="utf-8"?>
@@ -159,10 +422,9 @@
           <a:lstStyle/>
           <a:p>
             <a:r>
-              <a:rPr lang="en-US" smtClean="0"/>
+              <a:rPr lang="en-US"/>
               <a:t>Click to edit Master title style</a:t>
             </a:r>
-            <a:endParaRPr lang="en-US"/>
           </a:p>
         </p:txBody>
       </p:sp>
@@ -278,10 +540,9 @@
           </a:lstStyle>
           <a:p>
             <a:r>
-              <a:rPr lang="en-US" smtClean="0"/>
+              <a:rPr lang="en-US"/>
               <a:t>Click to edit Master subtitle style</a:t>
             </a:r>
-            <a:endParaRPr lang="en-US"/>
           </a:p>
         </p:txBody>
       </p:sp>
@@ -302,7 +563,7 @@
           <a:p>
             <a:fld id="{5BCAD085-E8A6-8845-BD4E-CB4CCA059FC4}" type="datetimeFigureOut">
               <a:rPr lang="en-US" smtClean="0"/>
-              <a:t>1/27/13</a:t>
+              <a:t>6/21/2026</a:t>
             </a:fld>
             <a:endParaRPr lang="en-US"/>
           </a:p>
@@ -396,10 +657,9 @@
           <a:lstStyle/>
           <a:p>
             <a:r>
-              <a:rPr lang="en-US" smtClean="0"/>
+              <a:rPr lang="en-US"/>
               <a:t>Click to edit Master title style</a:t>
             </a:r>
-            <a:endParaRPr lang="en-US"/>
           </a:p>
         </p:txBody>
       </p:sp>
@@ -420,38 +680,37 @@
           <a:p>
             <a:pPr lvl="0"/>
             <a:r>
-              <a:rPr lang="en-US" smtClean="0"/>
+              <a:rPr lang="en-US"/>
               <a:t>Click to edit Master text styles</a:t>
             </a:r>
           </a:p>
           <a:p>
             <a:pPr lvl="1"/>
             <a:r>
-              <a:rPr lang="en-US" smtClean="0"/>
+              <a:rPr lang="en-US"/>
               <a:t>Second level</a:t>
             </a:r>
           </a:p>
           <a:p>
             <a:pPr lvl="2"/>
             <a:r>
-              <a:rPr lang="en-US" smtClean="0"/>
+              <a:rPr lang="en-US"/>
               <a:t>Third level</a:t>
             </a:r>
           </a:p>
           <a:p>
             <a:pPr lvl="3"/>
             <a:r>
-              <a:rPr lang="en-US" smtClean="0"/>
+              <a:rPr lang="en-US"/>
               <a:t>Fourth level</a:t>
             </a:r>
           </a:p>
           <a:p>
             <a:pPr lvl="4"/>
             <a:r>
-              <a:rPr lang="en-US" smtClean="0"/>
+              <a:rPr lang="en-US"/>
               <a:t>Fifth level</a:t>
             </a:r>
-            <a:endParaRPr lang="en-US"/>
           </a:p>
         </p:txBody>
       </p:sp>
@@ -472,7 +731,7 @@
           <a:p>
             <a:fld id="{5BCAD085-E8A6-8845-BD4E-CB4CCA059FC4}" type="datetimeFigureOut">
               <a:rPr lang="en-US" smtClean="0"/>
-              <a:t>1/27/13</a:t>
+              <a:t>6/21/2026</a:t>
             </a:fld>
             <a:endParaRPr lang="en-US"/>
           </a:p>
@@ -571,10 +830,9 @@
           <a:lstStyle/>
           <a:p>
             <a:r>
-              <a:rPr lang="en-US" smtClean="0"/>
+              <a:rPr lang="en-US"/>
               <a:t>Click to edit Master title style</a:t>
             </a:r>
-            <a:endParaRPr lang="en-US"/>
           </a:p>
         </p:txBody>
       </p:sp>
@@ -600,38 +858,37 @@
           <a:p>
             <a:pPr lvl="0"/>
             <a:r>
-              <a:rPr lang="en-US" smtClean="0"/>
+              <a:rPr lang="en-US"/>
               <a:t>Click to edit Master text styles</a:t>
             </a:r>
           </a:p>
           <a:p>
             <a:pPr lvl="1"/>
             <a:r>
-              <a:rPr lang="en-US" smtClean="0"/>
+              <a:rPr lang="en-US"/>
               <a:t>Second level</a:t>
             </a:r>
           </a:p>
           <a:p>
             <a:pPr lvl="2"/>
             <a:r>
-              <a:rPr lang="en-US" smtClean="0"/>
+              <a:rPr lang="en-US"/>
               <a:t>Third level</a:t>
             </a:r>
           </a:p>
           <a:p>
             <a:pPr lvl="3"/>
             <a:r>
-              <a:rPr lang="en-US" smtClean="0"/>
+              <a:rPr lang="en-US"/>
               <a:t>Fourth level</a:t>
             </a:r>
           </a:p>
           <a:p>
             <a:pPr lvl="4"/>
             <a:r>
-              <a:rPr lang="en-US" smtClean="0"/>
+              <a:rPr lang="en-US"/>
               <a:t>Fifth level</a:t>
             </a:r>
-            <a:endParaRPr lang="en-US"/>
           </a:p>
         </p:txBody>
       </p:sp>
@@ -652,7 +909,7 @@
           <a:p>
             <a:fld id="{5BCAD085-E8A6-8845-BD4E-CB4CCA059FC4}" type="datetimeFigureOut">
               <a:rPr lang="en-US" smtClean="0"/>
-              <a:t>1/27/13</a:t>
+              <a:t>6/21/2026</a:t>
             </a:fld>
             <a:endParaRPr lang="en-US"/>
           </a:p>
@@ -746,10 +1003,9 @@
           <a:lstStyle/>
           <a:p>
             <a:r>
-              <a:rPr lang="en-US" smtClean="0"/>
+              <a:rPr lang="en-US"/>
               <a:t>Click to edit Master title style</a:t>
             </a:r>
-            <a:endParaRPr lang="en-US"/>
           </a:p>
         </p:txBody>
       </p:sp>
@@ -770,38 +1026,37 @@
           <a:p>
             <a:pPr lvl="0"/>
             <a:r>
-              <a:rPr lang="en-US" smtClean="0"/>
+              <a:rPr lang="en-US"/>
               <a:t>Click to edit Master text styles</a:t>
             </a:r>
           </a:p>
           <a:p>
             <a:pPr lvl="1"/>
             <a:r>
-              <a:rPr lang="en-US" smtClean="0"/>
+              <a:rPr lang="en-US"/>
               <a:t>Second level</a:t>
             </a:r>
           </a:p>
           <a:p>
             <a:pPr lvl="2"/>
             <a:r>
-              <a:rPr lang="en-US" smtClean="0"/>
+              <a:rPr lang="en-US"/>
               <a:t>Third level</a:t>
             </a:r>
           </a:p>
           <a:p>
             <a:pPr lvl="3"/>
             <a:r>
-              <a:rPr lang="en-US" smtClean="0"/>
+              <a:rPr lang="en-US"/>
               <a:t>Fourth level</a:t>
             </a:r>
           </a:p>
           <a:p>
             <a:pPr lvl="4"/>
             <a:r>
-              <a:rPr lang="en-US" smtClean="0"/>
+              <a:rPr lang="en-US"/>
               <a:t>Fifth level</a:t>
             </a:r>
-            <a:endParaRPr lang="en-US"/>
           </a:p>
         </p:txBody>
       </p:sp>
@@ -822,7 +1077,7 @@
           <a:p>
             <a:fld id="{5BCAD085-E8A6-8845-BD4E-CB4CCA059FC4}" type="datetimeFigureOut">
               <a:rPr lang="en-US" smtClean="0"/>
-              <a:t>1/27/13</a:t>
+              <a:t>6/21/2026</a:t>
             </a:fld>
             <a:endParaRPr lang="en-US"/>
           </a:p>
@@ -925,10 +1180,9 @@
           </a:lstStyle>
           <a:p>
             <a:r>
-              <a:rPr lang="en-US" smtClean="0"/>
+              <a:rPr lang="en-US"/>
               <a:t>Click to edit Master title style</a:t>
             </a:r>
-            <a:endParaRPr lang="en-US"/>
           </a:p>
         </p:txBody>
       </p:sp>
@@ -1045,7 +1299,7 @@
           <a:p>
             <a:pPr lvl="0"/>
             <a:r>
-              <a:rPr lang="en-US" smtClean="0"/>
+              <a:rPr lang="en-US"/>
               <a:t>Click to edit Master text styles</a:t>
             </a:r>
           </a:p>
@@ -1068,7 +1322,7 @@
           <a:p>
             <a:fld id="{5BCAD085-E8A6-8845-BD4E-CB4CCA059FC4}" type="datetimeFigureOut">
               <a:rPr lang="en-US" smtClean="0"/>
-              <a:t>1/27/13</a:t>
+              <a:t>6/21/2026</a:t>
             </a:fld>
             <a:endParaRPr lang="en-US"/>
           </a:p>
@@ -1162,10 +1416,9 @@
           <a:lstStyle/>
           <a:p>
             <a:r>
-              <a:rPr lang="en-US" smtClean="0"/>
+              <a:rPr lang="en-US"/>
               <a:t>Click to edit Master title style</a:t>
             </a:r>
-            <a:endParaRPr lang="en-US"/>
           </a:p>
         </p:txBody>
       </p:sp>
@@ -1219,38 +1472,37 @@
           <a:p>
             <a:pPr lvl="0"/>
             <a:r>
-              <a:rPr lang="en-US" smtClean="0"/>
+              <a:rPr lang="en-US"/>
               <a:t>Click to edit Master text styles</a:t>
             </a:r>
           </a:p>
           <a:p>
             <a:pPr lvl="1"/>
             <a:r>
-              <a:rPr lang="en-US" smtClean="0"/>
+              <a:rPr lang="en-US"/>
               <a:t>Second level</a:t>
             </a:r>
           </a:p>
           <a:p>
             <a:pPr lvl="2"/>
             <a:r>
-              <a:rPr lang="en-US" smtClean="0"/>
+              <a:rPr lang="en-US"/>
               <a:t>Third level</a:t>
             </a:r>
           </a:p>
           <a:p>
             <a:pPr lvl="3"/>
             <a:r>
-              <a:rPr lang="en-US" smtClean="0"/>
+              <a:rPr lang="en-US"/>
               <a:t>Fourth level</a:t>
             </a:r>
           </a:p>
           <a:p>
             <a:pPr lvl="4"/>
             <a:r>
-              <a:rPr lang="en-US" smtClean="0"/>
+              <a:rPr lang="en-US"/>
               <a:t>Fifth level</a:t>
             </a:r>
-            <a:endParaRPr lang="en-US"/>
           </a:p>
         </p:txBody>
       </p:sp>
@@ -1304,38 +1556,37 @@
           <a:p>
             <a:pPr lvl="0"/>
             <a:r>
-              <a:rPr lang="en-US" smtClean="0"/>
+              <a:rPr lang="en-US"/>
               <a:t>Click to edit Master text styles</a:t>
             </a:r>
           </a:p>
           <a:p>
             <a:pPr lvl="1"/>
             <a:r>
-              <a:rPr lang="en-US" smtClean="0"/>
+              <a:rPr lang="en-US"/>
               <a:t>Second level</a:t>
             </a:r>
           </a:p>
           <a:p>
             <a:pPr lvl="2"/>
             <a:r>
-              <a:rPr lang="en-US" smtClean="0"/>
+              <a:rPr lang="en-US"/>
               <a:t>Third level</a:t>
             </a:r>
           </a:p>
           <a:p>
             <a:pPr lvl="3"/>
             <a:r>
-              <a:rPr lang="en-US" smtClean="0"/>
+              <a:rPr lang="en-US"/>
               <a:t>Fourth level</a:t>
             </a:r>
           </a:p>
           <a:p>
             <a:pPr lvl="4"/>
             <a:r>
-              <a:rPr lang="en-US" smtClean="0"/>
+              <a:rPr lang="en-US"/>
               <a:t>Fifth level</a:t>
             </a:r>
-            <a:endParaRPr lang="en-US"/>
           </a:p>
         </p:txBody>
       </p:sp>
@@ -1356,7 +1607,7 @@
           <a:p>
             <a:fld id="{5BCAD085-E8A6-8845-BD4E-CB4CCA059FC4}" type="datetimeFigureOut">
               <a:rPr lang="en-US" smtClean="0"/>
-              <a:t>1/27/13</a:t>
+              <a:t>6/21/2026</a:t>
             </a:fld>
             <a:endParaRPr lang="en-US"/>
           </a:p>
@@ -1454,10 +1705,9 @@
           </a:lstStyle>
           <a:p>
             <a:r>
-              <a:rPr lang="en-US" smtClean="0"/>
+              <a:rPr lang="en-US"/>
               <a:t>Click to edit Master title style</a:t>
             </a:r>
-            <a:endParaRPr lang="en-US"/>
           </a:p>
         </p:txBody>
       </p:sp>
@@ -1520,7 +1770,7 @@
           <a:p>
             <a:pPr lvl="0"/>
             <a:r>
-              <a:rPr lang="en-US" smtClean="0"/>
+              <a:rPr lang="en-US"/>
               <a:t>Click to edit Master text styles</a:t>
             </a:r>
           </a:p>
@@ -1576,38 +1826,37 @@
           <a:p>
             <a:pPr lvl="0"/>
             <a:r>
-              <a:rPr lang="en-US" smtClean="0"/>
+              <a:rPr lang="en-US"/>
               <a:t>Click to edit Master text styles</a:t>
             </a:r>
           </a:p>
           <a:p>
             <a:pPr lvl="1"/>
             <a:r>
-              <a:rPr lang="en-US" smtClean="0"/>
+              <a:rPr lang="en-US"/>
               <a:t>Second level</a:t>
             </a:r>
           </a:p>
           <a:p>
             <a:pPr lvl="2"/>
             <a:r>
-              <a:rPr lang="en-US" smtClean="0"/>
+              <a:rPr lang="en-US"/>
               <a:t>Third level</a:t>
             </a:r>
           </a:p>
           <a:p>
             <a:pPr lvl="3"/>
             <a:r>
-              <a:rPr lang="en-US" smtClean="0"/>
+              <a:rPr lang="en-US"/>
               <a:t>Fourth level</a:t>
             </a:r>
           </a:p>
           <a:p>
             <a:pPr lvl="4"/>
             <a:r>
-              <a:rPr lang="en-US" smtClean="0"/>
+              <a:rPr lang="en-US"/>
               <a:t>Fifth level</a:t>
             </a:r>
-            <a:endParaRPr lang="en-US"/>
           </a:p>
         </p:txBody>
       </p:sp>
@@ -1670,7 +1919,7 @@
           <a:p>
             <a:pPr lvl="0"/>
             <a:r>
-              <a:rPr lang="en-US" smtClean="0"/>
+              <a:rPr lang="en-US"/>
               <a:t>Click to edit Master text styles</a:t>
             </a:r>
           </a:p>
@@ -1726,38 +1975,37 @@
           <a:p>
             <a:pPr lvl="0"/>
             <a:r>
-              <a:rPr lang="en-US" smtClean="0"/>
+              <a:rPr lang="en-US"/>
               <a:t>Click to edit Master text styles</a:t>
             </a:r>
           </a:p>
           <a:p>
             <a:pPr lvl="1"/>
             <a:r>
-              <a:rPr lang="en-US" smtClean="0"/>
+              <a:rPr lang="en-US"/>
               <a:t>Second level</a:t>
             </a:r>
           </a:p>
           <a:p>
             <a:pPr lvl="2"/>
             <a:r>
-              <a:rPr lang="en-US" smtClean="0"/>
+              <a:rPr lang="en-US"/>
               <a:t>Third level</a:t>
             </a:r>
           </a:p>
           <a:p>
             <a:pPr lvl="3"/>
             <a:r>
-              <a:rPr lang="en-US" smtClean="0"/>
+              <a:rPr lang="en-US"/>
               <a:t>Fourth level</a:t>
             </a:r>
           </a:p>
           <a:p>
             <a:pPr lvl="4"/>
             <a:r>
-              <a:rPr lang="en-US" smtClean="0"/>
+              <a:rPr lang="en-US"/>
               <a:t>Fifth level</a:t>
             </a:r>
-            <a:endParaRPr lang="en-US"/>
           </a:p>
         </p:txBody>
       </p:sp>
@@ -1778,7 +2026,7 @@
           <a:p>
             <a:fld id="{5BCAD085-E8A6-8845-BD4E-CB4CCA059FC4}" type="datetimeFigureOut">
               <a:rPr lang="en-US" smtClean="0"/>
-              <a:t>1/27/13</a:t>
+              <a:t>6/21/2026</a:t>
             </a:fld>
             <a:endParaRPr lang="en-US"/>
           </a:p>
@@ -1872,10 +2120,9 @@
           <a:lstStyle/>
           <a:p>
             <a:r>
-              <a:rPr lang="en-US" smtClean="0"/>
+              <a:rPr lang="en-US"/>
               <a:t>Click to edit Master title style</a:t>
             </a:r>
-            <a:endParaRPr lang="en-US"/>
           </a:p>
         </p:txBody>
       </p:sp>
@@ -1896,7 +2143,7 @@
           <a:p>
             <a:fld id="{5BCAD085-E8A6-8845-BD4E-CB4CCA059FC4}" type="datetimeFigureOut">
               <a:rPr lang="en-US" smtClean="0"/>
-              <a:t>1/27/13</a:t>
+              <a:t>6/21/2026</a:t>
             </a:fld>
             <a:endParaRPr lang="en-US"/>
           </a:p>
@@ -1991,7 +2238,7 @@
           <a:p>
             <a:fld id="{5BCAD085-E8A6-8845-BD4E-CB4CCA059FC4}" type="datetimeFigureOut">
               <a:rPr lang="en-US" smtClean="0"/>
-              <a:t>1/27/13</a:t>
+              <a:t>6/21/2026</a:t>
             </a:fld>
             <a:endParaRPr lang="en-US"/>
           </a:p>
@@ -2094,10 +2341,9 @@
           </a:lstStyle>
           <a:p>
             <a:r>
-              <a:rPr lang="en-US" smtClean="0"/>
+              <a:rPr lang="en-US"/>
               <a:t>Click to edit Master title style</a:t>
             </a:r>
-            <a:endParaRPr lang="en-US"/>
           </a:p>
         </p:txBody>
       </p:sp>
@@ -2151,38 +2397,37 @@
           <a:p>
             <a:pPr lvl="0"/>
             <a:r>
-              <a:rPr lang="en-US" smtClean="0"/>
+              <a:rPr lang="en-US"/>
               <a:t>Click to edit Master text styles</a:t>
             </a:r>
           </a:p>
           <a:p>
             <a:pPr lvl="1"/>
             <a:r>
-              <a:rPr lang="en-US" smtClean="0"/>
+              <a:rPr lang="en-US"/>
               <a:t>Second level</a:t>
             </a:r>
           </a:p>
           <a:p>
             <a:pPr lvl="2"/>
             <a:r>
-              <a:rPr lang="en-US" smtClean="0"/>
+              <a:rPr lang="en-US"/>
               <a:t>Third level</a:t>
             </a:r>
           </a:p>
           <a:p>
             <a:pPr lvl="3"/>
             <a:r>
-              <a:rPr lang="en-US" smtClean="0"/>
+              <a:rPr lang="en-US"/>
               <a:t>Fourth level</a:t>
             </a:r>
           </a:p>
           <a:p>
             <a:pPr lvl="4"/>
             <a:r>
-              <a:rPr lang="en-US" smtClean="0"/>
+              <a:rPr lang="en-US"/>
               <a:t>Fifth level</a:t>
             </a:r>
-            <a:endParaRPr lang="en-US"/>
           </a:p>
         </p:txBody>
       </p:sp>
@@ -2245,7 +2490,7 @@
           <a:p>
             <a:pPr lvl="0"/>
             <a:r>
-              <a:rPr lang="en-US" smtClean="0"/>
+              <a:rPr lang="en-US"/>
               <a:t>Click to edit Master text styles</a:t>
             </a:r>
           </a:p>
@@ -2268,7 +2513,7 @@
           <a:p>
             <a:fld id="{5BCAD085-E8A6-8845-BD4E-CB4CCA059FC4}" type="datetimeFigureOut">
               <a:rPr lang="en-US" smtClean="0"/>
-              <a:t>1/27/13</a:t>
+              <a:t>6/21/2026</a:t>
             </a:fld>
             <a:endParaRPr lang="en-US"/>
           </a:p>
@@ -2371,10 +2616,9 @@
           </a:lstStyle>
           <a:p>
             <a:r>
-              <a:rPr lang="en-US" smtClean="0"/>
+              <a:rPr lang="en-US"/>
               <a:t>Click to edit Master title style</a:t>
             </a:r>
-            <a:endParaRPr lang="en-US"/>
           </a:p>
         </p:txBody>
       </p:sp>
@@ -2498,7 +2742,7 @@
           <a:p>
             <a:pPr lvl="0"/>
             <a:r>
-              <a:rPr lang="en-US" smtClean="0"/>
+              <a:rPr lang="en-US"/>
               <a:t>Click to edit Master text styles</a:t>
             </a:r>
           </a:p>
@@ -2521,7 +2765,7 @@
           <a:p>
             <a:fld id="{5BCAD085-E8A6-8845-BD4E-CB4CCA059FC4}" type="datetimeFigureOut">
               <a:rPr lang="en-US" smtClean="0"/>
-              <a:t>1/27/13</a:t>
+              <a:t>6/21/2026</a:t>
             </a:fld>
             <a:endParaRPr lang="en-US"/>
           </a:p>
@@ -2630,10 +2874,9 @@
           <a:lstStyle/>
           <a:p>
             <a:r>
-              <a:rPr lang="en-US" smtClean="0"/>
+              <a:rPr lang="en-US"/>
               <a:t>Click to edit Master title style</a:t>
             </a:r>
-            <a:endParaRPr lang="en-US"/>
           </a:p>
         </p:txBody>
       </p:sp>
@@ -2664,38 +2907,37 @@
           <a:p>
             <a:pPr lvl="0"/>
             <a:r>
-              <a:rPr lang="en-US" smtClean="0"/>
+              <a:rPr lang="en-US"/>
               <a:t>Click to edit Master text styles</a:t>
             </a:r>
           </a:p>
           <a:p>
             <a:pPr lvl="1"/>
             <a:r>
-              <a:rPr lang="en-US" smtClean="0"/>
+              <a:rPr lang="en-US"/>
               <a:t>Second level</a:t>
             </a:r>
           </a:p>
           <a:p>
             <a:pPr lvl="2"/>
             <a:r>
-              <a:rPr lang="en-US" smtClean="0"/>
+              <a:rPr lang="en-US"/>
               <a:t>Third level</a:t>
             </a:r>
           </a:p>
           <a:p>
             <a:pPr lvl="3"/>
             <a:r>
-              <a:rPr lang="en-US" smtClean="0"/>
+              <a:rPr lang="en-US"/>
               <a:t>Fourth level</a:t>
             </a:r>
           </a:p>
           <a:p>
             <a:pPr lvl="4"/>
             <a:r>
-              <a:rPr lang="en-US" smtClean="0"/>
+              <a:rPr lang="en-US"/>
               <a:t>Fifth level</a:t>
             </a:r>
-            <a:endParaRPr lang="en-US"/>
           </a:p>
         </p:txBody>
       </p:sp>
@@ -2734,7 +2976,7 @@
           <a:p>
             <a:fld id="{5BCAD085-E8A6-8845-BD4E-CB4CCA059FC4}" type="datetimeFigureOut">
               <a:rPr lang="en-US" smtClean="0"/>
-              <a:t>1/27/13</a:t>
+              <a:t>6/21/2026</a:t>
             </a:fld>
             <a:endParaRPr lang="en-US"/>
           </a:p>
@@ -3093,7 +3335,7 @@
 </file>
 
 <file path=ppt/slides/slide1.xml><?xml version="1.0" encoding="utf-8"?>
-<p:sld xmlns:a="http://schemas.openxmlformats.org/drawingml/2006/main" xmlns:p="http://schemas.openxmlformats.org/presentationml/2006/main" xmlns:r="http://schemas.openxmlformats.org/officeDocument/2006/relationships">
+<p:sld xmlns:a="http://schemas.openxmlformats.org/drawingml/2006/main" xmlns:r="http://schemas.openxmlformats.org/officeDocument/2006/relationships" xmlns:p="http://schemas.openxmlformats.org/presentationml/2006/main">
   <p:cSld>
     <p:bg>
       <p:bgPr>
@@ -3109,7 +3351,14 @@
         <p:cNvGrpSpPr/>
         <p:nvPr/>
       </p:nvGrpSpPr>
-      <p:grpSpPr/>
+      <p:grpSpPr>
+        <a:xfrm>
+          <a:off x="0" y="0"/>
+          <a:ext cx="0" cy="0"/>
+          <a:chOff x="0" y="0"/>
+          <a:chExt cx="0" cy="0"/>
+        </a:xfrm>
+      </p:grpSpPr>
       <p:sp>
         <p:nvSpPr>
           <p:cNvPr id="2" name="Rounded Rectangle 1"/>
@@ -3152,42 +3401,7 @@
           <a:lstStyle/>
           <a:p>
             <a:pPr algn="ctr"/>
-          </a:p>
-        </p:txBody>
-      </p:sp>
-      <p:sp>
-        <p:nvSpPr>
-          <p:cNvPr id="3" name="TextBox 2"/>
-          <p:cNvSpPr txBox="1"/>
-          <p:nvPr/>
-        </p:nvSpPr>
-        <p:spPr>
-          <a:xfrm>
-            <a:off x="868680" y="1188720"/>
-            <a:ext cx="10454335" cy="365760"/>
-          </a:xfrm>
-          <a:prstGeom prst="rect">
-            <a:avLst/>
-          </a:prstGeom>
-          <a:noFill/>
-        </p:spPr>
-        <p:txBody>
-          <a:bodyPr wrap="square">
-            <a:spAutoFit/>
-          </a:bodyPr>
-          <a:lstStyle/>
-          <a:p>
-            <a:pPr>
-              <a:defRPr sz="1100" b="1">
-                <a:solidFill>
-                  <a:srgbClr val="06B6D4"/>
-                </a:solidFill>
-                <a:latin typeface="Consolas"/>
-              </a:defRPr>
-            </a:pPr>
-            <a:r>
-              <a:t>&gt; AI OBSERVATORY INITIALIZATION</a:t>
-            </a:r>
+            <a:endParaRPr/>
           </a:p>
         </p:txBody>
       </p:sp>
@@ -3277,6 +3491,7 @@
               </a:defRPr>
             </a:pPr>
             <a:r>
+              <a:rPr dirty="0"/>
               <a:t>▪  Developed by Moegamat Samsodien, 4th Year Computer Science, University of Cape Town</a:t>
             </a:r>
           </a:p>
@@ -3293,6 +3508,7 @@
               </a:defRPr>
             </a:pPr>
             <a:r>
+              <a:rPr dirty="0"/>
               <a:t>▪  Submission for the Global South AI Safety Hackathon</a:t>
             </a:r>
           </a:p>
@@ -3309,6 +3525,7 @@
               </a:defRPr>
             </a:pPr>
             <a:r>
+              <a:rPr dirty="0"/>
               <a:t>▪  Evaluating: GPT-4o-mini, Gemini 2.0 Flash, Claude Haiku, and Local Offline Fallbacks</a:t>
             </a:r>
           </a:p>
@@ -3323,7 +3540,7 @@
 </file>
 
 <file path=ppt/slides/slide10.xml><?xml version="1.0" encoding="utf-8"?>
-<p:sld xmlns:a="http://schemas.openxmlformats.org/drawingml/2006/main" xmlns:p="http://schemas.openxmlformats.org/presentationml/2006/main" xmlns:r="http://schemas.openxmlformats.org/officeDocument/2006/relationships">
+<p:sld xmlns:a="http://schemas.openxmlformats.org/drawingml/2006/main" xmlns:r="http://schemas.openxmlformats.org/officeDocument/2006/relationships" xmlns:p="http://schemas.openxmlformats.org/presentationml/2006/main">
   <p:cSld>
     <p:bg>
       <p:bgPr>
@@ -3339,43 +3556,14 @@
         <p:cNvGrpSpPr/>
         <p:nvPr/>
       </p:nvGrpSpPr>
-      <p:grpSpPr/>
-      <p:sp>
-        <p:nvSpPr>
-          <p:cNvPr id="2" name="TextBox 1"/>
-          <p:cNvSpPr txBox="1"/>
-          <p:nvPr/>
-        </p:nvSpPr>
-        <p:spPr>
-          <a:xfrm>
-            <a:off x="548640" y="365760"/>
-            <a:ext cx="10972800" cy="274320"/>
-          </a:xfrm>
-          <a:prstGeom prst="rect">
-            <a:avLst/>
-          </a:prstGeom>
-          <a:noFill/>
-        </p:spPr>
-        <p:txBody>
-          <a:bodyPr wrap="square">
-            <a:spAutoFit/>
-          </a:bodyPr>
-          <a:lstStyle/>
-          <a:p>
-            <a:pPr>
-              <a:defRPr sz="1000" b="1">
-                <a:solidFill>
-                  <a:srgbClr val="06B6D4"/>
-                </a:solidFill>
-                <a:latin typeface="Consolas"/>
-              </a:defRPr>
-            </a:pPr>
-            <a:r>
-              <a:t>// SYSTEM: THREAT INTELLIGENCE DASHBOARD</a:t>
-            </a:r>
-          </a:p>
-        </p:txBody>
-      </p:sp>
+      <p:grpSpPr>
+        <a:xfrm>
+          <a:off x="0" y="0"/>
+          <a:ext cx="0" cy="0"/>
+          <a:chOff x="0" y="0"/>
+          <a:chExt cx="0" cy="0"/>
+        </a:xfrm>
+      </p:grpSpPr>
       <p:sp>
         <p:nvSpPr>
           <p:cNvPr id="3" name="TextBox 2"/>
@@ -3541,6 +3729,7 @@
           <a:lstStyle/>
           <a:p>
             <a:pPr algn="ctr"/>
+            <a:endParaRPr/>
           </a:p>
         </p:txBody>
       </p:sp>
@@ -3620,6 +3809,7 @@
           <a:lstStyle/>
           <a:p>
             <a:pPr algn="ctr"/>
+            <a:endParaRPr/>
           </a:p>
         </p:txBody>
       </p:sp>
@@ -3646,7 +3836,7 @@
           <a:lstStyle/>
           <a:p>
             <a:pPr algn="ctr">
-              <a:defRPr b="1" sz="1100">
+              <a:defRPr sz="1100" b="1">
                 <a:solidFill>
                   <a:srgbClr val="F1F5F9"/>
                 </a:solidFill>
@@ -3701,6 +3891,7 @@
           <a:lstStyle/>
           <a:p>
             <a:pPr algn="ctr"/>
+            <a:endParaRPr/>
           </a:p>
         </p:txBody>
       </p:sp>
@@ -3769,7 +3960,7 @@
 </file>
 
 <file path=ppt/slides/slide11.xml><?xml version="1.0" encoding="utf-8"?>
-<p:sld xmlns:a="http://schemas.openxmlformats.org/drawingml/2006/main" xmlns:p="http://schemas.openxmlformats.org/presentationml/2006/main" xmlns:r="http://schemas.openxmlformats.org/officeDocument/2006/relationships">
+<p:sld xmlns:a="http://schemas.openxmlformats.org/drawingml/2006/main" xmlns:r="http://schemas.openxmlformats.org/officeDocument/2006/relationships" xmlns:p="http://schemas.openxmlformats.org/presentationml/2006/main">
   <p:cSld>
     <p:bg>
       <p:bgPr>
@@ -3785,43 +3976,14 @@
         <p:cNvGrpSpPr/>
         <p:nvPr/>
       </p:nvGrpSpPr>
-      <p:grpSpPr/>
-      <p:sp>
-        <p:nvSpPr>
-          <p:cNvPr id="2" name="TextBox 1"/>
-          <p:cNvSpPr txBox="1"/>
-          <p:nvPr/>
-        </p:nvSpPr>
-        <p:spPr>
-          <a:xfrm>
-            <a:off x="548640" y="365760"/>
-            <a:ext cx="10972800" cy="274320"/>
-          </a:xfrm>
-          <a:prstGeom prst="rect">
-            <a:avLst/>
-          </a:prstGeom>
-          <a:noFill/>
-        </p:spPr>
-        <p:txBody>
-          <a:bodyPr wrap="square">
-            <a:spAutoFit/>
-          </a:bodyPr>
-          <a:lstStyle/>
-          <a:p>
-            <a:pPr>
-              <a:defRPr sz="1000" b="1">
-                <a:solidFill>
-                  <a:srgbClr val="06B6D4"/>
-                </a:solidFill>
-                <a:latin typeface="Consolas"/>
-              </a:defRPr>
-            </a:pPr>
-            <a:r>
-              <a:t>// SYSTEM: TRUST &amp; SAFETY SIGNALS</a:t>
-            </a:r>
-          </a:p>
-        </p:txBody>
-      </p:sp>
+      <p:grpSpPr>
+        <a:xfrm>
+          <a:off x="0" y="0"/>
+          <a:ext cx="0" cy="0"/>
+          <a:chOff x="0" y="0"/>
+          <a:chExt cx="0" cy="0"/>
+        </a:xfrm>
+      </p:grpSpPr>
       <p:sp>
         <p:nvSpPr>
           <p:cNvPr id="3" name="TextBox 2"/>
@@ -3987,6 +4149,7 @@
           <a:lstStyle/>
           <a:p>
             <a:pPr algn="ctr"/>
+            <a:endParaRPr/>
           </a:p>
         </p:txBody>
       </p:sp>
@@ -4049,7 +4212,7 @@
           <a:lstStyle/>
           <a:p>
             <a:pPr algn="ctr">
-              <a:defRPr b="1" sz="4800">
+              <a:defRPr sz="4800" b="1">
                 <a:solidFill>
                   <a:srgbClr val="10B981"/>
                 </a:solidFill>
@@ -4120,6 +4283,7 @@
           <a:lstStyle/>
           <a:p>
             <a:pPr algn="ctr"/>
+            <a:endParaRPr/>
           </a:p>
         </p:txBody>
       </p:sp>
@@ -4182,7 +4346,7 @@
           <a:lstStyle/>
           <a:p>
             <a:pPr algn="ctr">
-              <a:defRPr b="1" sz="4800">
+              <a:defRPr sz="4800" b="1">
                 <a:solidFill>
                   <a:srgbClr val="06B6D4"/>
                 </a:solidFill>
@@ -4253,6 +4417,7 @@
           <a:lstStyle/>
           <a:p>
             <a:pPr algn="ctr"/>
+            <a:endParaRPr/>
           </a:p>
         </p:txBody>
       </p:sp>
@@ -4315,7 +4480,7 @@
           <a:lstStyle/>
           <a:p>
             <a:pPr algn="ctr">
-              <a:defRPr b="1" sz="4800">
+              <a:defRPr sz="4800" b="1">
                 <a:solidFill>
                   <a:srgbClr val="F59E0B"/>
                 </a:solidFill>
@@ -4386,6 +4551,7 @@
           <a:lstStyle/>
           <a:p>
             <a:pPr algn="ctr"/>
+            <a:endParaRPr/>
           </a:p>
         </p:txBody>
       </p:sp>
@@ -4448,7 +4614,7 @@
           <a:lstStyle/>
           <a:p>
             <a:pPr algn="ctr">
-              <a:defRPr b="1" sz="4800">
+              <a:defRPr sz="4800" b="1">
                 <a:solidFill>
                   <a:srgbClr val="94A3B8"/>
                 </a:solidFill>
@@ -4486,7 +4652,7 @@
 </file>
 
 <file path=ppt/slides/slide12.xml><?xml version="1.0" encoding="utf-8"?>
-<p:sld xmlns:a="http://schemas.openxmlformats.org/drawingml/2006/main" xmlns:p="http://schemas.openxmlformats.org/presentationml/2006/main" xmlns:r="http://schemas.openxmlformats.org/officeDocument/2006/relationships">
+<p:sld xmlns:a="http://schemas.openxmlformats.org/drawingml/2006/main" xmlns:r="http://schemas.openxmlformats.org/officeDocument/2006/relationships" xmlns:p="http://schemas.openxmlformats.org/presentationml/2006/main">
   <p:cSld>
     <p:bg>
       <p:bgPr>
@@ -4502,43 +4668,14 @@
         <p:cNvGrpSpPr/>
         <p:nvPr/>
       </p:nvGrpSpPr>
-      <p:grpSpPr/>
-      <p:sp>
-        <p:nvSpPr>
-          <p:cNvPr id="2" name="TextBox 1"/>
-          <p:cNvSpPr txBox="1"/>
-          <p:nvPr/>
-        </p:nvSpPr>
-        <p:spPr>
-          <a:xfrm>
-            <a:off x="548640" y="365760"/>
-            <a:ext cx="10972800" cy="274320"/>
-          </a:xfrm>
-          <a:prstGeom prst="rect">
-            <a:avLst/>
-          </a:prstGeom>
-          <a:noFill/>
-        </p:spPr>
-        <p:txBody>
-          <a:bodyPr wrap="square">
-            <a:spAutoFit/>
-          </a:bodyPr>
-          <a:lstStyle/>
-          <a:p>
-            <a:pPr>
-              <a:defRPr sz="1000" b="1">
-                <a:solidFill>
-                  <a:srgbClr val="06B6D4"/>
-                </a:solidFill>
-                <a:latin typeface="Consolas"/>
-              </a:defRPr>
-            </a:pPr>
-            <a:r>
-              <a:t>// SYSTEM: STACK SPECIFICATIONS</a:t>
-            </a:r>
-          </a:p>
-        </p:txBody>
-      </p:sp>
+      <p:grpSpPr>
+        <a:xfrm>
+          <a:off x="0" y="0"/>
+          <a:ext cx="0" cy="0"/>
+          <a:chOff x="0" y="0"/>
+          <a:chExt cx="0" cy="0"/>
+        </a:xfrm>
+      </p:grpSpPr>
       <p:sp>
         <p:nvSpPr>
           <p:cNvPr id="3" name="TextBox 2"/>
@@ -4617,6 +4754,7 @@
           <a:lstStyle/>
           <a:p>
             <a:pPr algn="ctr"/>
+            <a:endParaRPr/>
           </a:p>
         </p:txBody>
       </p:sp>
@@ -4801,6 +4939,7 @@
           <a:lstStyle/>
           <a:p>
             <a:pPr algn="ctr"/>
+            <a:endParaRPr/>
           </a:p>
         </p:txBody>
       </p:sp>
@@ -4985,6 +5124,7 @@
           <a:lstStyle/>
           <a:p>
             <a:pPr algn="ctr"/>
+            <a:endParaRPr/>
           </a:p>
         </p:txBody>
       </p:sp>
@@ -5169,6 +5309,7 @@
           <a:lstStyle/>
           <a:p>
             <a:pPr algn="ctr"/>
+            <a:endParaRPr/>
           </a:p>
         </p:txBody>
       </p:sp>
@@ -5320,7 +5461,7 @@
 </file>
 
 <file path=ppt/slides/slide13.xml><?xml version="1.0" encoding="utf-8"?>
-<p:sld xmlns:a="http://schemas.openxmlformats.org/drawingml/2006/main" xmlns:p="http://schemas.openxmlformats.org/presentationml/2006/main" xmlns:r="http://schemas.openxmlformats.org/officeDocument/2006/relationships">
+<p:sld xmlns:a="http://schemas.openxmlformats.org/drawingml/2006/main" xmlns:r="http://schemas.openxmlformats.org/officeDocument/2006/relationships" xmlns:p="http://schemas.openxmlformats.org/presentationml/2006/main">
   <p:cSld>
     <p:bg>
       <p:bgPr>
@@ -5336,43 +5477,14 @@
         <p:cNvGrpSpPr/>
         <p:nvPr/>
       </p:nvGrpSpPr>
-      <p:grpSpPr/>
-      <p:sp>
-        <p:nvSpPr>
-          <p:cNvPr id="2" name="TextBox 1"/>
-          <p:cNvSpPr txBox="1"/>
-          <p:nvPr/>
-        </p:nvSpPr>
-        <p:spPr>
-          <a:xfrm>
-            <a:off x="548640" y="365760"/>
-            <a:ext cx="10972800" cy="274320"/>
-          </a:xfrm>
-          <a:prstGeom prst="rect">
-            <a:avLst/>
-          </a:prstGeom>
-          <a:noFill/>
-        </p:spPr>
-        <p:txBody>
-          <a:bodyPr wrap="square">
-            <a:spAutoFit/>
-          </a:bodyPr>
-          <a:lstStyle/>
-          <a:p>
-            <a:pPr>
-              <a:defRPr sz="1000" b="1">
-                <a:solidFill>
-                  <a:srgbClr val="06B6D4"/>
-                </a:solidFill>
-                <a:latin typeface="Consolas"/>
-              </a:defRPr>
-            </a:pPr>
-            <a:r>
-              <a:t>// SYSTEM: ACADEMIC FOUNDATIONS</a:t>
-            </a:r>
-          </a:p>
-        </p:txBody>
-      </p:sp>
+      <p:grpSpPr>
+        <a:xfrm>
+          <a:off x="0" y="0"/>
+          <a:ext cx="0" cy="0"/>
+          <a:chOff x="0" y="0"/>
+          <a:chExt cx="0" cy="0"/>
+        </a:xfrm>
+      </p:grpSpPr>
       <p:sp>
         <p:nvSpPr>
           <p:cNvPr id="3" name="TextBox 2"/>
@@ -5538,6 +5650,7 @@
           <a:lstStyle/>
           <a:p>
             <a:pPr algn="ctr"/>
+            <a:endParaRPr/>
           </a:p>
         </p:txBody>
       </p:sp>
@@ -5619,7 +5732,7 @@
           <a:lstStyle/>
           <a:p>
             <a:pPr algn="ctr">
-              <a:defRPr b="1" sz="1100">
+              <a:defRPr sz="1100" b="1">
                 <a:solidFill>
                   <a:srgbClr val="F59E0B"/>
                 </a:solidFill>
@@ -5676,6 +5789,7 @@
           <a:lstStyle/>
           <a:p>
             <a:pPr algn="ctr"/>
+            <a:endParaRPr/>
           </a:p>
         </p:txBody>
       </p:sp>
@@ -5721,7 +5835,7 @@
           <a:lstStyle/>
           <a:p>
             <a:pPr algn="ctr">
-              <a:defRPr b="1" sz="1100">
+              <a:defRPr sz="1100" b="1">
                 <a:solidFill>
                   <a:srgbClr val="10B981"/>
                 </a:solidFill>
@@ -5751,7 +5865,7 @@
 </file>
 
 <file path=ppt/slides/slide14.xml><?xml version="1.0" encoding="utf-8"?>
-<p:sld xmlns:a="http://schemas.openxmlformats.org/drawingml/2006/main" xmlns:p="http://schemas.openxmlformats.org/presentationml/2006/main" xmlns:r="http://schemas.openxmlformats.org/officeDocument/2006/relationships">
+<p:sld xmlns:a="http://schemas.openxmlformats.org/drawingml/2006/main" xmlns:r="http://schemas.openxmlformats.org/officeDocument/2006/relationships" xmlns:p="http://schemas.openxmlformats.org/presentationml/2006/main">
   <p:cSld>
     <p:bg>
       <p:bgPr>
@@ -5767,43 +5881,14 @@
         <p:cNvGrpSpPr/>
         <p:nvPr/>
       </p:nvGrpSpPr>
-      <p:grpSpPr/>
-      <p:sp>
-        <p:nvSpPr>
-          <p:cNvPr id="2" name="TextBox 1"/>
-          <p:cNvSpPr txBox="1"/>
-          <p:nvPr/>
-        </p:nvSpPr>
-        <p:spPr>
-          <a:xfrm>
-            <a:off x="548640" y="365760"/>
-            <a:ext cx="10972800" cy="274320"/>
-          </a:xfrm>
-          <a:prstGeom prst="rect">
-            <a:avLst/>
-          </a:prstGeom>
-          <a:noFill/>
-        </p:spPr>
-        <p:txBody>
-          <a:bodyPr wrap="square">
-            <a:spAutoFit/>
-          </a:bodyPr>
-          <a:lstStyle/>
-          <a:p>
-            <a:pPr>
-              <a:defRPr sz="1000" b="1">
-                <a:solidFill>
-                  <a:srgbClr val="06B6D4"/>
-                </a:solidFill>
-                <a:latin typeface="Consolas"/>
-              </a:defRPr>
-            </a:pPr>
-            <a:r>
-              <a:t>// SYSTEM: PROJECT DIAGNOSTICS</a:t>
-            </a:r>
-          </a:p>
-        </p:txBody>
-      </p:sp>
+      <p:grpSpPr>
+        <a:xfrm>
+          <a:off x="0" y="0"/>
+          <a:ext cx="0" cy="0"/>
+          <a:chOff x="0" y="0"/>
+          <a:chExt cx="0" cy="0"/>
+        </a:xfrm>
+      </p:grpSpPr>
       <p:sp>
         <p:nvSpPr>
           <p:cNvPr id="3" name="TextBox 2"/>
@@ -5882,6 +5967,7 @@
           <a:lstStyle/>
           <a:p>
             <a:pPr algn="ctr"/>
+            <a:endParaRPr/>
           </a:p>
         </p:txBody>
       </p:sp>
@@ -6050,6 +6136,7 @@
           <a:lstStyle/>
           <a:p>
             <a:pPr algn="ctr"/>
+            <a:endParaRPr/>
           </a:p>
         </p:txBody>
       </p:sp>
@@ -6185,7 +6272,7 @@
 </file>
 
 <file path=ppt/slides/slide15.xml><?xml version="1.0" encoding="utf-8"?>
-<p:sld xmlns:a="http://schemas.openxmlformats.org/drawingml/2006/main" xmlns:p="http://schemas.openxmlformats.org/presentationml/2006/main" xmlns:r="http://schemas.openxmlformats.org/officeDocument/2006/relationships">
+<p:sld xmlns:a="http://schemas.openxmlformats.org/drawingml/2006/main" xmlns:r="http://schemas.openxmlformats.org/officeDocument/2006/relationships" xmlns:p="http://schemas.openxmlformats.org/presentationml/2006/main">
   <p:cSld>
     <p:bg>
       <p:bgPr>
@@ -6201,17 +6288,24 @@
         <p:cNvGrpSpPr/>
         <p:nvPr/>
       </p:nvGrpSpPr>
-      <p:grpSpPr/>
-      <p:sp>
-        <p:nvSpPr>
-          <p:cNvPr id="2" name="TextBox 1"/>
+      <p:grpSpPr>
+        <a:xfrm>
+          <a:off x="0" y="0"/>
+          <a:ext cx="0" cy="0"/>
+          <a:chOff x="0" y="0"/>
+          <a:chExt cx="0" cy="0"/>
+        </a:xfrm>
+      </p:grpSpPr>
+      <p:sp>
+        <p:nvSpPr>
+          <p:cNvPr id="3" name="TextBox 2"/>
           <p:cNvSpPr txBox="1"/>
           <p:nvPr/>
         </p:nvSpPr>
         <p:spPr>
           <a:xfrm>
-            <a:off x="548640" y="365760"/>
-            <a:ext cx="10972800" cy="274320"/>
+            <a:off x="548640" y="548640"/>
+            <a:ext cx="10972800" cy="731520"/>
           </a:xfrm>
           <a:prstGeom prst="rect">
             <a:avLst/>
@@ -6225,42 +6319,6 @@
           <a:lstStyle/>
           <a:p>
             <a:pPr>
-              <a:defRPr sz="1000" b="1">
-                <a:solidFill>
-                  <a:srgbClr val="06B6D4"/>
-                </a:solidFill>
-                <a:latin typeface="Consolas"/>
-              </a:defRPr>
-            </a:pPr>
-            <a:r>
-              <a:t>// SYSTEM: PLATFORM STATUS</a:t>
-            </a:r>
-          </a:p>
-        </p:txBody>
-      </p:sp>
-      <p:sp>
-        <p:nvSpPr>
-          <p:cNvPr id="3" name="TextBox 2"/>
-          <p:cNvSpPr txBox="1"/>
-          <p:nvPr/>
-        </p:nvSpPr>
-        <p:spPr>
-          <a:xfrm>
-            <a:off x="548640" y="548640"/>
-            <a:ext cx="10972800" cy="731520"/>
-          </a:xfrm>
-          <a:prstGeom prst="rect">
-            <a:avLst/>
-          </a:prstGeom>
-          <a:noFill/>
-        </p:spPr>
-        <p:txBody>
-          <a:bodyPr wrap="square">
-            <a:spAutoFit/>
-          </a:bodyPr>
-          <a:lstStyle/>
-          <a:p>
-            <a:pPr>
               <a:defRPr sz="2800" b="1">
                 <a:solidFill>
                   <a:srgbClr val="F1F5F9"/>
@@ -6269,6 +6327,7 @@
               </a:defRPr>
             </a:pPr>
             <a:r>
+              <a:rPr dirty="0"/>
               <a:t>Securing AI Systems for Everyone, Everywhere</a:t>
             </a:r>
           </a:p>
@@ -6316,42 +6375,7 @@
           <a:lstStyle/>
           <a:p>
             <a:pPr algn="ctr"/>
-          </a:p>
-        </p:txBody>
-      </p:sp>
-      <p:sp>
-        <p:nvSpPr>
-          <p:cNvPr id="5" name="TextBox 4"/>
-          <p:cNvSpPr txBox="1"/>
-          <p:nvPr/>
-        </p:nvSpPr>
-        <p:spPr>
-          <a:xfrm>
-            <a:off x="868680" y="1463040"/>
-            <a:ext cx="10454335" cy="365760"/>
-          </a:xfrm>
-          <a:prstGeom prst="rect">
-            <a:avLst/>
-          </a:prstGeom>
-          <a:noFill/>
-        </p:spPr>
-        <p:txBody>
-          <a:bodyPr wrap="square">
-            <a:spAutoFit/>
-          </a:bodyPr>
-          <a:lstStyle/>
-          <a:p>
-            <a:pPr>
-              <a:defRPr sz="1100" b="1">
-                <a:solidFill>
-                  <a:srgbClr val="06B6D4"/>
-                </a:solidFill>
-                <a:latin typeface="Consolas"/>
-              </a:defRPr>
-            </a:pPr>
-            <a:r>
-              <a:t>&gt; OBSERVATORY PLATFORM INITIALIZED SUCCESSFULLY</a:t>
-            </a:r>
+            <a:endParaRPr/>
           </a:p>
         </p:txBody>
       </p:sp>
@@ -6378,7 +6402,7 @@
           <a:lstStyle/>
           <a:p>
             <a:pPr algn="ctr">
-              <a:defRPr b="1" sz="2800">
+              <a:defRPr sz="2800" b="1">
                 <a:solidFill>
                   <a:srgbClr val="F1F5F9"/>
                 </a:solidFill>
@@ -6445,11 +6469,11 @@
           </a:fontRef>
         </p:style>
         <p:txBody>
-          <a:bodyPr rtlCol="0" anchor="ctr" wrap="square"/>
+          <a:bodyPr wrap="square" rtlCol="0" anchor="ctr"/>
           <a:lstStyle/>
           <a:p>
             <a:pPr algn="ctr">
-              <a:defRPr b="1" sz="1100">
+              <a:defRPr sz="1100" b="1">
                 <a:solidFill>
                   <a:srgbClr val="06B6D4"/>
                 </a:solidFill>
@@ -6520,11 +6544,11 @@
           </a:fontRef>
         </p:style>
         <p:txBody>
-          <a:bodyPr rtlCol="0" anchor="ctr" wrap="square"/>
+          <a:bodyPr wrap="square" rtlCol="0" anchor="ctr"/>
           <a:lstStyle/>
           <a:p>
             <a:pPr algn="ctr">
-              <a:defRPr b="1" sz="1100">
+              <a:defRPr sz="1100" b="1">
                 <a:solidFill>
                   <a:srgbClr val="F59E0B"/>
                 </a:solidFill>
@@ -6595,11 +6619,11 @@
           </a:fontRef>
         </p:style>
         <p:txBody>
-          <a:bodyPr rtlCol="0" anchor="ctr" wrap="square"/>
+          <a:bodyPr wrap="square" rtlCol="0" anchor="ctr"/>
           <a:lstStyle/>
           <a:p>
             <a:pPr algn="ctr">
-              <a:defRPr b="1" sz="1100">
+              <a:defRPr sz="1100" b="1">
                 <a:solidFill>
                   <a:srgbClr val="10B981"/>
                 </a:solidFill>
@@ -6607,6 +6631,7 @@
               </a:defRPr>
             </a:pPr>
             <a:r>
+              <a:rPr dirty="0"/>
               <a:t>COLLABORATION HUB</a:t>
             </a:r>
           </a:p>
@@ -6623,10 +6648,14 @@
               </a:defRPr>
             </a:pPr>
             <a:r>
+              <a:rPr dirty="0"/>
               <a:t>Dataset Contributions &amp; Red Teaming</a:t>
             </a:r>
-            <a:br/>
-            <a:r>
+            <a:br>
+              <a:rPr dirty="0"/>
+            </a:br>
+            <a:r>
+              <a:rPr dirty="0"/>
               <a:t>samsodien@uct.ac.za</a:t>
             </a:r>
           </a:p>
@@ -6641,7 +6670,7 @@
 </file>
 
 <file path=ppt/slides/slide2.xml><?xml version="1.0" encoding="utf-8"?>
-<p:sld xmlns:a="http://schemas.openxmlformats.org/drawingml/2006/main" xmlns:p="http://schemas.openxmlformats.org/presentationml/2006/main" xmlns:r="http://schemas.openxmlformats.org/officeDocument/2006/relationships">
+<p:sld xmlns:a="http://schemas.openxmlformats.org/drawingml/2006/main" xmlns:r="http://schemas.openxmlformats.org/officeDocument/2006/relationships" xmlns:p="http://schemas.openxmlformats.org/presentationml/2006/main">
   <p:cSld>
     <p:bg>
       <p:bgPr>
@@ -6657,43 +6686,14 @@
         <p:cNvGrpSpPr/>
         <p:nvPr/>
       </p:nvGrpSpPr>
-      <p:grpSpPr/>
-      <p:sp>
-        <p:nvSpPr>
-          <p:cNvPr id="2" name="TextBox 1"/>
-          <p:cNvSpPr txBox="1"/>
-          <p:nvPr/>
-        </p:nvSpPr>
-        <p:spPr>
-          <a:xfrm>
-            <a:off x="548640" y="365760"/>
-            <a:ext cx="10972800" cy="274320"/>
-          </a:xfrm>
-          <a:prstGeom prst="rect">
-            <a:avLst/>
-          </a:prstGeom>
-          <a:noFill/>
-        </p:spPr>
-        <p:txBody>
-          <a:bodyPr wrap="square">
-            <a:spAutoFit/>
-          </a:bodyPr>
-          <a:lstStyle/>
-          <a:p>
-            <a:pPr>
-              <a:defRPr sz="1000" b="1">
-                <a:solidFill>
-                  <a:srgbClr val="06B6D4"/>
-                </a:solidFill>
-                <a:latin typeface="Consolas"/>
-              </a:defRPr>
-            </a:pPr>
-            <a:r>
-              <a:t>// SYSTEM: THREAT INTELLIGENCE</a:t>
-            </a:r>
-          </a:p>
-        </p:txBody>
-      </p:sp>
+      <p:grpSpPr>
+        <a:xfrm>
+          <a:off x="0" y="0"/>
+          <a:ext cx="0" cy="0"/>
+          <a:chOff x="0" y="0"/>
+          <a:chExt cx="0" cy="0"/>
+        </a:xfrm>
+      </p:grpSpPr>
       <p:sp>
         <p:nvSpPr>
           <p:cNvPr id="3" name="TextBox 2"/>
@@ -6859,6 +6859,7 @@
           <a:lstStyle/>
           <a:p>
             <a:pPr algn="ctr"/>
+            <a:endParaRPr/>
           </a:p>
         </p:txBody>
       </p:sp>
@@ -6940,6 +6941,7 @@
           <a:lstStyle/>
           <a:p>
             <a:pPr algn="ctr"/>
+            <a:endParaRPr/>
           </a:p>
         </p:txBody>
       </p:sp>
@@ -7061,6 +7063,7 @@
           <a:lstStyle/>
           <a:p>
             <a:pPr algn="ctr"/>
+            <a:endParaRPr/>
           </a:p>
         </p:txBody>
       </p:sp>
@@ -7153,7 +7156,7 @@
 </file>
 
 <file path=ppt/slides/slide3.xml><?xml version="1.0" encoding="utf-8"?>
-<p:sld xmlns:a="http://schemas.openxmlformats.org/drawingml/2006/main" xmlns:p="http://schemas.openxmlformats.org/presentationml/2006/main" xmlns:r="http://schemas.openxmlformats.org/officeDocument/2006/relationships">
+<p:sld xmlns:a="http://schemas.openxmlformats.org/drawingml/2006/main" xmlns:r="http://schemas.openxmlformats.org/officeDocument/2006/relationships" xmlns:p="http://schemas.openxmlformats.org/presentationml/2006/main">
   <p:cSld>
     <p:bg>
       <p:bgPr>
@@ -7169,43 +7172,14 @@
         <p:cNvGrpSpPr/>
         <p:nvPr/>
       </p:nvGrpSpPr>
-      <p:grpSpPr/>
-      <p:sp>
-        <p:nvSpPr>
-          <p:cNvPr id="2" name="TextBox 1"/>
-          <p:cNvSpPr txBox="1"/>
-          <p:nvPr/>
-        </p:nvSpPr>
-        <p:spPr>
-          <a:xfrm>
-            <a:off x="548640" y="365760"/>
-            <a:ext cx="10972800" cy="274320"/>
-          </a:xfrm>
-          <a:prstGeom prst="rect">
-            <a:avLst/>
-          </a:prstGeom>
-          <a:noFill/>
-        </p:spPr>
-        <p:txBody>
-          <a:bodyPr wrap="square">
-            <a:spAutoFit/>
-          </a:bodyPr>
-          <a:lstStyle/>
-          <a:p>
-            <a:pPr>
-              <a:defRPr sz="1000" b="1">
-                <a:solidFill>
-                  <a:srgbClr val="06B6D4"/>
-                </a:solidFill>
-                <a:latin typeface="Consolas"/>
-              </a:defRPr>
-            </a:pPr>
-            <a:r>
-              <a:t>// SYSTEM: REGIONAL LANDSCAPE</a:t>
-            </a:r>
-          </a:p>
-        </p:txBody>
-      </p:sp>
+      <p:grpSpPr>
+        <a:xfrm>
+          <a:off x="0" y="0"/>
+          <a:ext cx="0" cy="0"/>
+          <a:chOff x="0" y="0"/>
+          <a:chExt cx="0" cy="0"/>
+        </a:xfrm>
+      </p:grpSpPr>
       <p:sp>
         <p:nvSpPr>
           <p:cNvPr id="3" name="TextBox 2"/>
@@ -7371,6 +7345,7 @@
           <a:lstStyle/>
           <a:p>
             <a:pPr algn="ctr"/>
+            <a:endParaRPr/>
           </a:p>
         </p:txBody>
       </p:sp>
@@ -7433,7 +7408,7 @@
           <a:lstStyle/>
           <a:p>
             <a:pPr>
-              <a:defRPr b="1" sz="1400">
+              <a:defRPr sz="1400" b="1">
                 <a:solidFill>
                   <a:srgbClr val="F1F5F9"/>
                 </a:solidFill>
@@ -7479,7 +7454,7 @@
 </file>
 
 <file path=ppt/slides/slide4.xml><?xml version="1.0" encoding="utf-8"?>
-<p:sld xmlns:a="http://schemas.openxmlformats.org/drawingml/2006/main" xmlns:p="http://schemas.openxmlformats.org/presentationml/2006/main" xmlns:r="http://schemas.openxmlformats.org/officeDocument/2006/relationships">
+<p:sld xmlns:a="http://schemas.openxmlformats.org/drawingml/2006/main" xmlns:r="http://schemas.openxmlformats.org/officeDocument/2006/relationships" xmlns:p="http://schemas.openxmlformats.org/presentationml/2006/main">
   <p:cSld>
     <p:bg>
       <p:bgPr>
@@ -7495,43 +7470,14 @@
         <p:cNvGrpSpPr/>
         <p:nvPr/>
       </p:nvGrpSpPr>
-      <p:grpSpPr/>
-      <p:sp>
-        <p:nvSpPr>
-          <p:cNvPr id="2" name="TextBox 1"/>
-          <p:cNvSpPr txBox="1"/>
-          <p:nvPr/>
-        </p:nvSpPr>
-        <p:spPr>
-          <a:xfrm>
-            <a:off x="548640" y="365760"/>
-            <a:ext cx="10972800" cy="274320"/>
-          </a:xfrm>
-          <a:prstGeom prst="rect">
-            <a:avLst/>
-          </a:prstGeom>
-          <a:noFill/>
-        </p:spPr>
-        <p:txBody>
-          <a:bodyPr wrap="square">
-            <a:spAutoFit/>
-          </a:bodyPr>
-          <a:lstStyle/>
-          <a:p>
-            <a:pPr>
-              <a:defRPr sz="1000" b="1">
-                <a:solidFill>
-                  <a:srgbClr val="06B6D4"/>
-                </a:solidFill>
-                <a:latin typeface="Consolas"/>
-              </a:defRPr>
-            </a:pPr>
-            <a:r>
-              <a:t>// SYSTEM: TECHNICAL SOLUTION</a:t>
-            </a:r>
-          </a:p>
-        </p:txBody>
-      </p:sp>
+      <p:grpSpPr>
+        <a:xfrm>
+          <a:off x="0" y="0"/>
+          <a:ext cx="0" cy="0"/>
+          <a:chOff x="0" y="0"/>
+          <a:chExt cx="0" cy="0"/>
+        </a:xfrm>
+      </p:grpSpPr>
       <p:sp>
         <p:nvSpPr>
           <p:cNvPr id="3" name="TextBox 2"/>
@@ -7697,6 +7643,7 @@
           <a:lstStyle/>
           <a:p>
             <a:pPr algn="ctr"/>
+            <a:endParaRPr/>
           </a:p>
         </p:txBody>
       </p:sp>
@@ -7778,6 +7725,7 @@
           <a:lstStyle/>
           <a:p>
             <a:pPr algn="ctr"/>
+            <a:endParaRPr/>
           </a:p>
         </p:txBody>
       </p:sp>
@@ -7867,6 +7815,7 @@
           <a:lstStyle/>
           <a:p>
             <a:pPr algn="ctr"/>
+            <a:endParaRPr/>
           </a:p>
         </p:txBody>
       </p:sp>
@@ -7956,6 +7905,7 @@
           <a:lstStyle/>
           <a:p>
             <a:pPr algn="ctr"/>
+            <a:endParaRPr/>
           </a:p>
         </p:txBody>
       </p:sp>
@@ -8016,7 +7966,7 @@
 </file>
 
 <file path=ppt/slides/slide5.xml><?xml version="1.0" encoding="utf-8"?>
-<p:sld xmlns:a="http://schemas.openxmlformats.org/drawingml/2006/main" xmlns:p="http://schemas.openxmlformats.org/presentationml/2006/main" xmlns:r="http://schemas.openxmlformats.org/officeDocument/2006/relationships">
+<p:sld xmlns:a="http://schemas.openxmlformats.org/drawingml/2006/main" xmlns:r="http://schemas.openxmlformats.org/officeDocument/2006/relationships" xmlns:p="http://schemas.openxmlformats.org/presentationml/2006/main">
   <p:cSld>
     <p:bg>
       <p:bgPr>
@@ -8032,43 +7982,14 @@
         <p:cNvGrpSpPr/>
         <p:nvPr/>
       </p:nvGrpSpPr>
-      <p:grpSpPr/>
-      <p:sp>
-        <p:nvSpPr>
-          <p:cNvPr id="2" name="TextBox 1"/>
-          <p:cNvSpPr txBox="1"/>
-          <p:nvPr/>
-        </p:nvSpPr>
-        <p:spPr>
-          <a:xfrm>
-            <a:off x="548640" y="365760"/>
-            <a:ext cx="10972800" cy="274320"/>
-          </a:xfrm>
-          <a:prstGeom prst="rect">
-            <a:avLst/>
-          </a:prstGeom>
-          <a:noFill/>
-        </p:spPr>
-        <p:txBody>
-          <a:bodyPr wrap="square">
-            <a:spAutoFit/>
-          </a:bodyPr>
-          <a:lstStyle/>
-          <a:p>
-            <a:pPr>
-              <a:defRPr sz="1000" b="1">
-                <a:solidFill>
-                  <a:srgbClr val="06B6D4"/>
-                </a:solidFill>
-                <a:latin typeface="Consolas"/>
-              </a:defRPr>
-            </a:pPr>
-            <a:r>
-              <a:t>// SYSTEM: ARCHITECTURE BLUEPRINT</a:t>
-            </a:r>
-          </a:p>
-        </p:txBody>
-      </p:sp>
+      <p:grpSpPr>
+        <a:xfrm>
+          <a:off x="0" y="0"/>
+          <a:ext cx="0" cy="0"/>
+          <a:chOff x="0" y="0"/>
+          <a:chExt cx="0" cy="0"/>
+        </a:xfrm>
+      </p:grpSpPr>
       <p:sp>
         <p:nvSpPr>
           <p:cNvPr id="3" name="TextBox 2"/>
@@ -8234,6 +8155,7 @@
           <a:lstStyle/>
           <a:p>
             <a:pPr algn="ctr"/>
+            <a:endParaRPr/>
           </a:p>
         </p:txBody>
       </p:sp>
@@ -8311,7 +8233,7 @@
           </a:fontRef>
         </p:style>
         <p:txBody>
-          <a:bodyPr rtlCol="0" anchor="ctr" wrap="square"/>
+          <a:bodyPr wrap="square" rtlCol="0" anchor="ctr"/>
           <a:lstStyle/>
           <a:p>
             <a:pPr algn="ctr">
@@ -8382,7 +8304,7 @@
           </a:fontRef>
         </p:style>
         <p:txBody>
-          <a:bodyPr rtlCol="0" anchor="ctr" wrap="square"/>
+          <a:bodyPr wrap="square" rtlCol="0" anchor="ctr"/>
           <a:lstStyle/>
           <a:p>
             <a:pPr algn="ctr">
@@ -8453,7 +8375,7 @@
           </a:fontRef>
         </p:style>
         <p:txBody>
-          <a:bodyPr rtlCol="0" anchor="ctr" wrap="square"/>
+          <a:bodyPr wrap="square" rtlCol="0" anchor="ctr"/>
           <a:lstStyle/>
           <a:p>
             <a:pPr algn="ctr">
@@ -8524,7 +8446,7 @@
           </a:fontRef>
         </p:style>
         <p:txBody>
-          <a:bodyPr rtlCol="0" anchor="ctr" wrap="square"/>
+          <a:bodyPr wrap="square" rtlCol="0" anchor="ctr"/>
           <a:lstStyle/>
           <a:p>
             <a:pPr algn="ctr">
@@ -8595,7 +8517,7 @@
           </a:fontRef>
         </p:style>
         <p:txBody>
-          <a:bodyPr rtlCol="0" anchor="ctr" wrap="square"/>
+          <a:bodyPr wrap="square" rtlCol="0" anchor="ctr"/>
           <a:lstStyle/>
           <a:p>
             <a:pPr algn="ctr">
@@ -8637,7 +8559,7 @@
 </file>
 
 <file path=ppt/slides/slide6.xml><?xml version="1.0" encoding="utf-8"?>
-<p:sld xmlns:a="http://schemas.openxmlformats.org/drawingml/2006/main" xmlns:p="http://schemas.openxmlformats.org/presentationml/2006/main" xmlns:r="http://schemas.openxmlformats.org/officeDocument/2006/relationships">
+<p:sld xmlns:a="http://schemas.openxmlformats.org/drawingml/2006/main" xmlns:r="http://schemas.openxmlformats.org/officeDocument/2006/relationships" xmlns:p="http://schemas.openxmlformats.org/presentationml/2006/main">
   <p:cSld>
     <p:bg>
       <p:bgPr>
@@ -8653,43 +8575,14 @@
         <p:cNvGrpSpPr/>
         <p:nvPr/>
       </p:nvGrpSpPr>
-      <p:grpSpPr/>
-      <p:sp>
-        <p:nvSpPr>
-          <p:cNvPr id="2" name="TextBox 1"/>
-          <p:cNvSpPr txBox="1"/>
-          <p:nvPr/>
-        </p:nvSpPr>
-        <p:spPr>
-          <a:xfrm>
-            <a:off x="548640" y="365760"/>
-            <a:ext cx="10972800" cy="274320"/>
-          </a:xfrm>
-          <a:prstGeom prst="rect">
-            <a:avLst/>
-          </a:prstGeom>
-          <a:noFill/>
-        </p:spPr>
-        <p:txBody>
-          <a:bodyPr wrap="square">
-            <a:spAutoFit/>
-          </a:bodyPr>
-          <a:lstStyle/>
-          <a:p>
-            <a:pPr>
-              <a:defRPr sz="1000" b="1">
-                <a:solidFill>
-                  <a:srgbClr val="06B6D4"/>
-                </a:solidFill>
-                <a:latin typeface="Consolas"/>
-              </a:defRPr>
-            </a:pPr>
-            <a:r>
-              <a:t>// SYSTEM: SYSTEM MODULES</a:t>
-            </a:r>
-          </a:p>
-        </p:txBody>
-      </p:sp>
+      <p:grpSpPr>
+        <a:xfrm>
+          <a:off x="0" y="0"/>
+          <a:ext cx="0" cy="0"/>
+          <a:chOff x="0" y="0"/>
+          <a:chExt cx="0" cy="0"/>
+        </a:xfrm>
+      </p:grpSpPr>
       <p:sp>
         <p:nvSpPr>
           <p:cNvPr id="3" name="TextBox 2"/>
@@ -8768,6 +8661,7 @@
           <a:lstStyle/>
           <a:p>
             <a:pPr algn="ctr"/>
+            <a:endParaRPr/>
           </a:p>
         </p:txBody>
       </p:sp>
@@ -8885,6 +8779,7 @@
           <a:lstStyle/>
           <a:p>
             <a:pPr algn="ctr"/>
+            <a:endParaRPr/>
           </a:p>
         </p:txBody>
       </p:sp>
@@ -9002,6 +8897,7 @@
           <a:lstStyle/>
           <a:p>
             <a:pPr algn="ctr"/>
+            <a:endParaRPr/>
           </a:p>
         </p:txBody>
       </p:sp>
@@ -9119,6 +9015,7 @@
           <a:lstStyle/>
           <a:p>
             <a:pPr algn="ctr"/>
+            <a:endParaRPr/>
           </a:p>
         </p:txBody>
       </p:sp>
@@ -9236,6 +9133,7 @@
           <a:lstStyle/>
           <a:p>
             <a:pPr algn="ctr"/>
+            <a:endParaRPr/>
           </a:p>
         </p:txBody>
       </p:sp>
@@ -9353,6 +9251,7 @@
           <a:lstStyle/>
           <a:p>
             <a:pPr algn="ctr"/>
+            <a:endParaRPr/>
           </a:p>
         </p:txBody>
       </p:sp>
@@ -9437,7 +9336,7 @@
 </file>
 
 <file path=ppt/slides/slide7.xml><?xml version="1.0" encoding="utf-8"?>
-<p:sld xmlns:a="http://schemas.openxmlformats.org/drawingml/2006/main" xmlns:p="http://schemas.openxmlformats.org/presentationml/2006/main" xmlns:r="http://schemas.openxmlformats.org/officeDocument/2006/relationships">
+<p:sld xmlns:a="http://schemas.openxmlformats.org/drawingml/2006/main" xmlns:r="http://schemas.openxmlformats.org/officeDocument/2006/relationships" xmlns:p="http://schemas.openxmlformats.org/presentationml/2006/main">
   <p:cSld>
     <p:bg>
       <p:bgPr>
@@ -9453,43 +9352,14 @@
         <p:cNvGrpSpPr/>
         <p:nvPr/>
       </p:nvGrpSpPr>
-      <p:grpSpPr/>
-      <p:sp>
-        <p:nvSpPr>
-          <p:cNvPr id="2" name="TextBox 1"/>
-          <p:cNvSpPr txBox="1"/>
-          <p:nvPr/>
-        </p:nvSpPr>
-        <p:spPr>
-          <a:xfrm>
-            <a:off x="548640" y="365760"/>
-            <a:ext cx="10972800" cy="274320"/>
-          </a:xfrm>
-          <a:prstGeom prst="rect">
-            <a:avLst/>
-          </a:prstGeom>
-          <a:noFill/>
-        </p:spPr>
-        <p:txBody>
-          <a:bodyPr wrap="square">
-            <a:spAutoFit/>
-          </a:bodyPr>
-          <a:lstStyle/>
-          <a:p>
-            <a:pPr>
-              <a:defRPr sz="1000" b="1">
-                <a:solidFill>
-                  <a:srgbClr val="06B6D4"/>
-                </a:solidFill>
-                <a:latin typeface="Consolas"/>
-              </a:defRPr>
-            </a:pPr>
-            <a:r>
-              <a:t>// SYSTEM: VULNERABILITY ASSESSMENT</a:t>
-            </a:r>
-          </a:p>
-        </p:txBody>
-      </p:sp>
+      <p:grpSpPr>
+        <a:xfrm>
+          <a:off x="0" y="0"/>
+          <a:ext cx="0" cy="0"/>
+          <a:chOff x="0" y="0"/>
+          <a:chExt cx="0" cy="0"/>
+        </a:xfrm>
+      </p:grpSpPr>
       <p:sp>
         <p:nvSpPr>
           <p:cNvPr id="3" name="TextBox 2"/>
@@ -9671,6 +9541,7 @@
           <a:lstStyle/>
           <a:p>
             <a:pPr algn="ctr"/>
+            <a:endParaRPr/>
           </a:p>
         </p:txBody>
       </p:sp>
@@ -9752,6 +9623,7 @@
           <a:lstStyle/>
           <a:p>
             <a:pPr algn="ctr"/>
+            <a:endParaRPr/>
           </a:p>
         </p:txBody>
       </p:sp>
@@ -9877,6 +9749,7 @@
           <a:lstStyle/>
           <a:p>
             <a:pPr algn="ctr"/>
+            <a:endParaRPr/>
           </a:p>
         </p:txBody>
       </p:sp>
@@ -9969,7 +9842,7 @@
 </file>
 
 <file path=ppt/slides/slide8.xml><?xml version="1.0" encoding="utf-8"?>
-<p:sld xmlns:a="http://schemas.openxmlformats.org/drawingml/2006/main" xmlns:p="http://schemas.openxmlformats.org/presentationml/2006/main" xmlns:r="http://schemas.openxmlformats.org/officeDocument/2006/relationships">
+<p:sld xmlns:a="http://schemas.openxmlformats.org/drawingml/2006/main" xmlns:r="http://schemas.openxmlformats.org/officeDocument/2006/relationships" xmlns:p="http://schemas.openxmlformats.org/presentationml/2006/main">
   <p:cSld>
     <p:bg>
       <p:bgPr>
@@ -9985,43 +9858,14 @@
         <p:cNvGrpSpPr/>
         <p:nvPr/>
       </p:nvGrpSpPr>
-      <p:grpSpPr/>
-      <p:sp>
-        <p:nvSpPr>
-          <p:cNvPr id="2" name="TextBox 1"/>
-          <p:cNvSpPr txBox="1"/>
-          <p:nvPr/>
-        </p:nvSpPr>
-        <p:spPr>
-          <a:xfrm>
-            <a:off x="548640" y="365760"/>
-            <a:ext cx="10972800" cy="274320"/>
-          </a:xfrm>
-          <a:prstGeom prst="rect">
-            <a:avLst/>
-          </a:prstGeom>
-          <a:noFill/>
-        </p:spPr>
-        <p:txBody>
-          <a:bodyPr wrap="square">
-            <a:spAutoFit/>
-          </a:bodyPr>
-          <a:lstStyle/>
-          <a:p>
-            <a:pPr>
-              <a:defRPr sz="1000" b="1">
-                <a:solidFill>
-                  <a:srgbClr val="06B6D4"/>
-                </a:solidFill>
-                <a:latin typeface="Consolas"/>
-              </a:defRPr>
-            </a:pPr>
-            <a:r>
-              <a:t>// SYSTEM: METHODOLOGY</a:t>
-            </a:r>
-          </a:p>
-        </p:txBody>
-      </p:sp>
+      <p:grpSpPr>
+        <a:xfrm>
+          <a:off x="0" y="0"/>
+          <a:ext cx="0" cy="0"/>
+          <a:chOff x="0" y="0"/>
+          <a:chExt cx="0" cy="0"/>
+        </a:xfrm>
+      </p:grpSpPr>
       <p:sp>
         <p:nvSpPr>
           <p:cNvPr id="3" name="TextBox 2"/>
@@ -10187,6 +10031,7 @@
           <a:lstStyle/>
           <a:p>
             <a:pPr algn="ctr"/>
+            <a:endParaRPr/>
           </a:p>
         </p:txBody>
       </p:sp>
@@ -10245,8 +10090,20 @@
                 <a:tableStyleId>{5C22544A-7EE6-4342-B048-85BDC9FD1C3A}</a:tableStyleId>
               </a:tblPr>
               <a:tblGrid>
-                <a:gridCol w="1828800"/>
-                <a:gridCol w="2926080"/>
+                <a:gridCol w="1828800">
+                  <a:extLst>
+                    <a:ext uri="{9D8B030D-6E8A-4147-A177-3AD203B41FA5}">
+                      <a16:colId xmlns:a16="http://schemas.microsoft.com/office/drawing/2014/main" val="20000"/>
+                    </a:ext>
+                  </a:extLst>
+                </a:gridCol>
+                <a:gridCol w="2926080">
+                  <a:extLst>
+                    <a:ext uri="{9D8B030D-6E8A-4147-A177-3AD203B41FA5}">
+                      <a16:colId xmlns:a16="http://schemas.microsoft.com/office/drawing/2014/main" val="20001"/>
+                    </a:ext>
+                  </a:extLst>
+                </a:gridCol>
               </a:tblGrid>
               <a:tr h="457200">
                 <a:tc>
@@ -10297,6 +10154,11 @@
                     </a:solidFill>
                   </a:tcPr>
                 </a:tc>
+                <a:extLst>
+                  <a:ext uri="{0D108BD9-81ED-4DB2-BD59-A6C34878D82A}">
+                    <a16:rowId xmlns:a16="http://schemas.microsoft.com/office/drawing/2014/main" val="10000"/>
+                  </a:ext>
+                </a:extLst>
               </a:tr>
               <a:tr h="457200">
                 <a:tc>
@@ -10347,6 +10209,11 @@
                     </a:solidFill>
                   </a:tcPr>
                 </a:tc>
+                <a:extLst>
+                  <a:ext uri="{0D108BD9-81ED-4DB2-BD59-A6C34878D82A}">
+                    <a16:rowId xmlns:a16="http://schemas.microsoft.com/office/drawing/2014/main" val="10001"/>
+                  </a:ext>
+                </a:extLst>
               </a:tr>
               <a:tr h="457200">
                 <a:tc>
@@ -10397,6 +10264,11 @@
                     </a:solidFill>
                   </a:tcPr>
                 </a:tc>
+                <a:extLst>
+                  <a:ext uri="{0D108BD9-81ED-4DB2-BD59-A6C34878D82A}">
+                    <a16:rowId xmlns:a16="http://schemas.microsoft.com/office/drawing/2014/main" val="10002"/>
+                  </a:ext>
+                </a:extLst>
               </a:tr>
               <a:tr h="457200">
                 <a:tc>
@@ -10447,6 +10319,11 @@
                     </a:solidFill>
                   </a:tcPr>
                 </a:tc>
+                <a:extLst>
+                  <a:ext uri="{0D108BD9-81ED-4DB2-BD59-A6C34878D82A}">
+                    <a16:rowId xmlns:a16="http://schemas.microsoft.com/office/drawing/2014/main" val="10003"/>
+                  </a:ext>
+                </a:extLst>
               </a:tr>
               <a:tr h="457200">
                 <a:tc>
@@ -10497,6 +10374,11 @@
                     </a:solidFill>
                   </a:tcPr>
                 </a:tc>
+                <a:extLst>
+                  <a:ext uri="{0D108BD9-81ED-4DB2-BD59-A6C34878D82A}">
+                    <a16:rowId xmlns:a16="http://schemas.microsoft.com/office/drawing/2014/main" val="10004"/>
+                  </a:ext>
+                </a:extLst>
               </a:tr>
               <a:tr h="457200">
                 <a:tc>
@@ -10547,6 +10429,11 @@
                     </a:solidFill>
                   </a:tcPr>
                 </a:tc>
+                <a:extLst>
+                  <a:ext uri="{0D108BD9-81ED-4DB2-BD59-A6C34878D82A}">
+                    <a16:rowId xmlns:a16="http://schemas.microsoft.com/office/drawing/2014/main" val="10005"/>
+                  </a:ext>
+                </a:extLst>
               </a:tr>
               <a:tr h="457200">
                 <a:tc>
@@ -10597,6 +10484,11 @@
                     </a:solidFill>
                   </a:tcPr>
                 </a:tc>
+                <a:extLst>
+                  <a:ext uri="{0D108BD9-81ED-4DB2-BD59-A6C34878D82A}">
+                    <a16:rowId xmlns:a16="http://schemas.microsoft.com/office/drawing/2014/main" val="10006"/>
+                  </a:ext>
+                </a:extLst>
               </a:tr>
             </a:tbl>
           </a:graphicData>
@@ -10611,7 +10503,7 @@
 </file>
 
 <file path=ppt/slides/slide9.xml><?xml version="1.0" encoding="utf-8"?>
-<p:sld xmlns:a="http://schemas.openxmlformats.org/drawingml/2006/main" xmlns:p="http://schemas.openxmlformats.org/presentationml/2006/main" xmlns:r="http://schemas.openxmlformats.org/officeDocument/2006/relationships">
+<p:sld xmlns:a="http://schemas.openxmlformats.org/drawingml/2006/main" xmlns:r="http://schemas.openxmlformats.org/officeDocument/2006/relationships" xmlns:p="http://schemas.openxmlformats.org/presentationml/2006/main">
   <p:cSld>
     <p:bg>
       <p:bgPr>
@@ -10627,43 +10519,14 @@
         <p:cNvGrpSpPr/>
         <p:nvPr/>
       </p:nvGrpSpPr>
-      <p:grpSpPr/>
-      <p:sp>
-        <p:nvSpPr>
-          <p:cNvPr id="2" name="TextBox 1"/>
-          <p:cNvSpPr txBox="1"/>
-          <p:nvPr/>
-        </p:nvSpPr>
-        <p:spPr>
-          <a:xfrm>
-            <a:off x="548640" y="365760"/>
-            <a:ext cx="10972800" cy="274320"/>
-          </a:xfrm>
-          <a:prstGeom prst="rect">
-            <a:avLst/>
-          </a:prstGeom>
-          <a:noFill/>
-        </p:spPr>
-        <p:txBody>
-          <a:bodyPr wrap="square">
-            <a:spAutoFit/>
-          </a:bodyPr>
-          <a:lstStyle/>
-          <a:p>
-            <a:pPr>
-              <a:defRPr sz="1000" b="1">
-                <a:solidFill>
-                  <a:srgbClr val="06B6D4"/>
-                </a:solidFill>
-                <a:latin typeface="Consolas"/>
-              </a:defRPr>
-            </a:pPr>
-            <a:r>
-              <a:t>// SYSTEM: EMPIRICAL FINDINGS</a:t>
-            </a:r>
-          </a:p>
-        </p:txBody>
-      </p:sp>
+      <p:grpSpPr>
+        <a:xfrm>
+          <a:off x="0" y="0"/>
+          <a:ext cx="0" cy="0"/>
+          <a:chOff x="0" y="0"/>
+          <a:chExt cx="0" cy="0"/>
+        </a:xfrm>
+      </p:grpSpPr>
       <p:sp>
         <p:nvSpPr>
           <p:cNvPr id="3" name="TextBox 2"/>
@@ -10829,6 +10692,7 @@
           <a:lstStyle/>
           <a:p>
             <a:pPr algn="ctr"/>
+            <a:endParaRPr/>
           </a:p>
         </p:txBody>
       </p:sp>
@@ -10944,6 +10808,7 @@
           <a:lstStyle/>
           <a:p>
             <a:pPr algn="ctr"/>
+            <a:endParaRPr/>
           </a:p>
         </p:txBody>
       </p:sp>
@@ -10987,6 +10852,7 @@
           <a:lstStyle/>
           <a:p>
             <a:pPr algn="ctr"/>
+            <a:endParaRPr/>
           </a:p>
         </p:txBody>
       </p:sp>
@@ -11102,6 +10968,7 @@
           <a:lstStyle/>
           <a:p>
             <a:pPr algn="ctr"/>
+            <a:endParaRPr/>
           </a:p>
         </p:txBody>
       </p:sp>
@@ -11145,6 +11012,7 @@
           <a:lstStyle/>
           <a:p>
             <a:pPr algn="ctr"/>
+            <a:endParaRPr/>
           </a:p>
         </p:txBody>
       </p:sp>
@@ -11260,6 +11128,7 @@
           <a:lstStyle/>
           <a:p>
             <a:pPr algn="ctr"/>
+            <a:endParaRPr/>
           </a:p>
         </p:txBody>
       </p:sp>
@@ -11303,6 +11172,7 @@
           <a:lstStyle/>
           <a:p>
             <a:pPr algn="ctr"/>
+            <a:endParaRPr/>
           </a:p>
         </p:txBody>
       </p:sp>
@@ -11418,6 +11288,7 @@
           <a:lstStyle/>
           <a:p>
             <a:pPr algn="ctr"/>
+            <a:endParaRPr/>
           </a:p>
         </p:txBody>
       </p:sp>
@@ -11461,6 +11332,7 @@
           <a:lstStyle/>
           <a:p>
             <a:pPr algn="ctr"/>
+            <a:endParaRPr/>
           </a:p>
         </p:txBody>
       </p:sp>
@@ -11576,6 +11448,7 @@
           <a:lstStyle/>
           <a:p>
             <a:pPr algn="ctr"/>
+            <a:endParaRPr/>
           </a:p>
         </p:txBody>
       </p:sp>
@@ -11619,6 +11492,7 @@
           <a:lstStyle/>
           <a:p>
             <a:pPr algn="ctr"/>
+            <a:endParaRPr/>
           </a:p>
         </p:txBody>
       </p:sp>
@@ -11734,6 +11608,7 @@
           <a:lstStyle/>
           <a:p>
             <a:pPr algn="ctr"/>
+            <a:endParaRPr/>
           </a:p>
         </p:txBody>
       </p:sp>
@@ -11777,6 +11652,7 @@
           <a:lstStyle/>
           <a:p>
             <a:pPr algn="ctr"/>
+            <a:endParaRPr/>
           </a:p>
         </p:txBody>
       </p:sp>

</xml_diff>